<commit_message>
Add 3D operating diorama, layperson story, dark theme, and Pages deploy
- Replace the raster cutaway with a procedural WebGL2 hospital campus
  (React Three Fiber): 9 zones, camera choreography per story beat,
  world-space actor routes, state semantics, 2D fallback ladder
- Rewrite pressures/receipts in layperson language with a metric
  translation layer; dashboard relabeled for executives
- Unify the dark theme across Portfolio, modal, radar, and light blocks
- Rebuild the use-case modal: decision strip, evidence-basis card,
  taxonomy hover tooltips
- Add world/motion-3d check contracts and a GitHub Pages workflow

Co-Authored-By: Claude Fable 5 <noreply@anthropic.com>
</commit_message>
<xml_diff>
--- a/outputs/AI-Transforming-Hospital-Operations-SRS-2026.pptx
+++ b/outputs/AI-Transforming-Hospital-Operations-SRS-2026.pptx
@@ -2,28 +2,28 @@
 <file path=ppt/presentation.xml><?xml version="1.0" encoding="utf-8"?>
 <p:presentation xmlns:p="http://schemas.openxmlformats.org/presentationml/2006/main">
   <p:sldMasterIdLst>
-    <p:sldMasterId xmlns:r="http://schemas.openxmlformats.org/officeDocument/2006/relationships" id="2147483648" r:id="Ra756ebda8e544ff1"/>
+    <p:sldMasterId xmlns:r="http://schemas.openxmlformats.org/officeDocument/2006/relationships" id="2147483648" r:id="R044b2fc02b404d16"/>
   </p:sldMasterIdLst>
   <p:notesMasterIdLst>
-    <p:notesMasterId xmlns:r="http://schemas.openxmlformats.org/officeDocument/2006/relationships" r:id="R6abd22e0fa314727"/>
+    <p:notesMasterId xmlns:r="http://schemas.openxmlformats.org/officeDocument/2006/relationships" r:id="R72e23c200ce9409e"/>
   </p:notesMasterIdLst>
   <p:sldIdLst>
-    <p:sldId xmlns:r="http://schemas.openxmlformats.org/officeDocument/2006/relationships" id="256" r:id="R138f23958a274a4f"/>
-    <p:sldId xmlns:r="http://schemas.openxmlformats.org/officeDocument/2006/relationships" id="257" r:id="R8a9b99c8c6374fbf"/>
-    <p:sldId xmlns:r="http://schemas.openxmlformats.org/officeDocument/2006/relationships" id="258" r:id="Rf6177f5291fd4c1c"/>
-    <p:sldId xmlns:r="http://schemas.openxmlformats.org/officeDocument/2006/relationships" id="259" r:id="Rb6f2329dc2d34cfa"/>
-    <p:sldId xmlns:r="http://schemas.openxmlformats.org/officeDocument/2006/relationships" id="260" r:id="R1348f3f0f0cd4540"/>
-    <p:sldId xmlns:r="http://schemas.openxmlformats.org/officeDocument/2006/relationships" id="261" r:id="R673fbf304ff04640"/>
-    <p:sldId xmlns:r="http://schemas.openxmlformats.org/officeDocument/2006/relationships" id="262" r:id="Raf25bf298a9d4264"/>
-    <p:sldId xmlns:r="http://schemas.openxmlformats.org/officeDocument/2006/relationships" id="263" r:id="R22a40250c7324013"/>
-    <p:sldId xmlns:r="http://schemas.openxmlformats.org/officeDocument/2006/relationships" id="264" r:id="R045ee8b3cdec4d13"/>
-    <p:sldId xmlns:r="http://schemas.openxmlformats.org/officeDocument/2006/relationships" id="265" r:id="R451da572a90e47e3"/>
-    <p:sldId xmlns:r="http://schemas.openxmlformats.org/officeDocument/2006/relationships" id="266" r:id="R92e73b1202bd4991"/>
-    <p:sldId xmlns:r="http://schemas.openxmlformats.org/officeDocument/2006/relationships" id="267" r:id="Rec473b6c5648495e"/>
-    <p:sldId xmlns:r="http://schemas.openxmlformats.org/officeDocument/2006/relationships" id="268" r:id="R2df208edeae247c6"/>
-    <p:sldId xmlns:r="http://schemas.openxmlformats.org/officeDocument/2006/relationships" id="269" r:id="R745bbaa9cf69471c"/>
-    <p:sldId xmlns:r="http://schemas.openxmlformats.org/officeDocument/2006/relationships" id="270" r:id="R76f6643c64d14e0a"/>
-    <p:sldId xmlns:r="http://schemas.openxmlformats.org/officeDocument/2006/relationships" id="271" r:id="R7b8efbe29ac2445a"/>
+    <p:sldId xmlns:r="http://schemas.openxmlformats.org/officeDocument/2006/relationships" id="256" r:id="Reaf301f62ffb43b7"/>
+    <p:sldId xmlns:r="http://schemas.openxmlformats.org/officeDocument/2006/relationships" id="257" r:id="R6058cfe560be4f9b"/>
+    <p:sldId xmlns:r="http://schemas.openxmlformats.org/officeDocument/2006/relationships" id="258" r:id="R84ed21b8761e454a"/>
+    <p:sldId xmlns:r="http://schemas.openxmlformats.org/officeDocument/2006/relationships" id="259" r:id="R4b3768bd17ed4c39"/>
+    <p:sldId xmlns:r="http://schemas.openxmlformats.org/officeDocument/2006/relationships" id="260" r:id="R3e2fb4f1ff674af1"/>
+    <p:sldId xmlns:r="http://schemas.openxmlformats.org/officeDocument/2006/relationships" id="261" r:id="R11f1219991a64212"/>
+    <p:sldId xmlns:r="http://schemas.openxmlformats.org/officeDocument/2006/relationships" id="262" r:id="R0c1b024d6d9a4be4"/>
+    <p:sldId xmlns:r="http://schemas.openxmlformats.org/officeDocument/2006/relationships" id="263" r:id="R339f2819780f4e1d"/>
+    <p:sldId xmlns:r="http://schemas.openxmlformats.org/officeDocument/2006/relationships" id="264" r:id="R8943bf8c0a2b4699"/>
+    <p:sldId xmlns:r="http://schemas.openxmlformats.org/officeDocument/2006/relationships" id="265" r:id="Re7804ae970a3442e"/>
+    <p:sldId xmlns:r="http://schemas.openxmlformats.org/officeDocument/2006/relationships" id="266" r:id="Ra7ec408c736b462b"/>
+    <p:sldId xmlns:r="http://schemas.openxmlformats.org/officeDocument/2006/relationships" id="267" r:id="Ra02cbdae90b0476d"/>
+    <p:sldId xmlns:r="http://schemas.openxmlformats.org/officeDocument/2006/relationships" id="268" r:id="R28c96d457aca4b48"/>
+    <p:sldId xmlns:r="http://schemas.openxmlformats.org/officeDocument/2006/relationships" id="269" r:id="Rcf26e1dd06404285"/>
+    <p:sldId xmlns:r="http://schemas.openxmlformats.org/officeDocument/2006/relationships" id="270" r:id="Rb3a883befd294b54"/>
+    <p:sldId xmlns:r="http://schemas.openxmlformats.org/officeDocument/2006/relationships" id="271" r:id="R69730f542fa34a9f"/>
   </p:sldIdLst>
   <p:sldSz cx="12192000" cy="6858000"/>
   <p:notesSz cx="6858000" cy="9144000"/>
@@ -1700,7 +1700,7 @@
   </p:cSld>
   <p:clrMap bg1="lt1" tx1="dk1" bg2="lt2" tx2="dk2" accent1="accent1" accent2="accent2" accent3="accent3" accent4="accent4" accent5="accent5" accent6="accent6" hlink="hlink" folHlink="folHlink"/>
   <p:sldLayoutIdLst>
-    <p:sldLayoutId xmlns:r="http://schemas.openxmlformats.org/officeDocument/2006/relationships" id="2147483649" r:id="R37792025d10d421b"/>
+    <p:sldLayoutId xmlns:r="http://schemas.openxmlformats.org/officeDocument/2006/relationships" id="2147483649" r:id="Rc53f13a6b7c04913"/>
   </p:sldLayoutIdLst>
   <p:txStyles>
     <p:titleStyle>
@@ -3240,6 +3240,7 @@
           <a:lstStyle xmlns:a="http://schemas.openxmlformats.org/drawingml/2006/main"/>
           <a:p xmlns:a="http://schemas.openxmlformats.org/drawingml/2006/main">
             <a:pPr algn="l">
+              <a:buNone/>
               <a:defRPr sz="900" b="1">
                 <a:solidFill>
                   <a:srgbClr val="83F3C9"/>
@@ -3296,6 +3297,7 @@
           <a:lstStyle xmlns:a="http://schemas.openxmlformats.org/drawingml/2006/main"/>
           <a:p xmlns:a="http://schemas.openxmlformats.org/drawingml/2006/main">
             <a:pPr algn="l">
+              <a:buNone/>
               <a:defRPr sz="4500" b="1">
                 <a:solidFill>
                   <a:srgbClr val="F7F8F5"/>
@@ -3319,6 +3321,7 @@
           </a:p>
           <a:p xmlns:a="http://schemas.openxmlformats.org/drawingml/2006/main">
             <a:pPr algn="l">
+              <a:buNone/>
               <a:defRPr sz="4500" b="1">
                 <a:solidFill>
                   <a:srgbClr val="F7F8F5"/>
@@ -3375,6 +3378,7 @@
           <a:lstStyle xmlns:a="http://schemas.openxmlformats.org/drawingml/2006/main"/>
           <a:p xmlns:a="http://schemas.openxmlformats.org/drawingml/2006/main">
             <a:pPr algn="l">
+              <a:buNone/>
               <a:defRPr sz="1800" b="0">
                 <a:solidFill>
                   <a:srgbClr val="C2CDD1"/>
@@ -3398,6 +3402,7 @@
           </a:p>
           <a:p xmlns:a="http://schemas.openxmlformats.org/drawingml/2006/main">
             <a:pPr algn="l">
+              <a:buNone/>
               <a:defRPr sz="1800" b="0">
                 <a:solidFill>
                   <a:srgbClr val="C2CDD1"/>
@@ -3489,6 +3494,7 @@
           <a:lstStyle xmlns:a="http://schemas.openxmlformats.org/drawingml/2006/main"/>
           <a:p xmlns:a="http://schemas.openxmlformats.org/drawingml/2006/main">
             <a:pPr algn="l">
+              <a:buNone/>
               <a:defRPr sz="825" b="1">
                 <a:solidFill>
                   <a:srgbClr val="9AA8AE"/>
@@ -3545,6 +3551,7 @@
           <a:lstStyle xmlns:a="http://schemas.openxmlformats.org/drawingml/2006/main"/>
           <a:p xmlns:a="http://schemas.openxmlformats.org/drawingml/2006/main">
             <a:pPr algn="l">
+              <a:buNone/>
               <a:defRPr sz="5400" b="0">
                 <a:solidFill>
                   <a:srgbClr val="F7F8F5"/>
@@ -3601,6 +3608,7 @@
           <a:lstStyle xmlns:a="http://schemas.openxmlformats.org/drawingml/2006/main"/>
           <a:p xmlns:a="http://schemas.openxmlformats.org/drawingml/2006/main">
             <a:pPr algn="l">
+              <a:buNone/>
               <a:defRPr sz="1125" b="0">
                 <a:solidFill>
                   <a:srgbClr val="9AA8AE"/>
@@ -3688,6 +3696,7 @@
           <a:lstStyle xmlns:a="http://schemas.openxmlformats.org/drawingml/2006/main"/>
           <a:p xmlns:a="http://schemas.openxmlformats.org/drawingml/2006/main">
             <a:pPr algn="l">
+              <a:buNone/>
               <a:defRPr sz="1125" b="0">
                 <a:solidFill>
                   <a:srgbClr val="C6D0D3"/>
@@ -3744,6 +3753,7 @@
           <a:lstStyle xmlns:a="http://schemas.openxmlformats.org/drawingml/2006/main"/>
           <a:p xmlns:a="http://schemas.openxmlformats.org/drawingml/2006/main">
             <a:pPr algn="r">
+              <a:buNone/>
               <a:defRPr sz="975" b="1">
                 <a:solidFill>
                   <a:srgbClr val="F7F8F5"/>
@@ -3831,6 +3841,7 @@
           <a:lstStyle xmlns:a="http://schemas.openxmlformats.org/drawingml/2006/main"/>
           <a:p xmlns:a="http://schemas.openxmlformats.org/drawingml/2006/main">
             <a:pPr algn="l">
+              <a:buNone/>
               <a:defRPr sz="1125" b="0">
                 <a:solidFill>
                   <a:srgbClr val="C6D0D3"/>
@@ -3887,6 +3898,7 @@
           <a:lstStyle xmlns:a="http://schemas.openxmlformats.org/drawingml/2006/main"/>
           <a:p xmlns:a="http://schemas.openxmlformats.org/drawingml/2006/main">
             <a:pPr algn="r">
+              <a:buNone/>
               <a:defRPr sz="975" b="1">
                 <a:solidFill>
                   <a:srgbClr val="F7F8F5"/>
@@ -3974,6 +3986,7 @@
           <a:lstStyle xmlns:a="http://schemas.openxmlformats.org/drawingml/2006/main"/>
           <a:p xmlns:a="http://schemas.openxmlformats.org/drawingml/2006/main">
             <a:pPr algn="l">
+              <a:buNone/>
               <a:defRPr sz="1125" b="0">
                 <a:solidFill>
                   <a:srgbClr val="C6D0D3"/>
@@ -4030,6 +4043,7 @@
           <a:lstStyle xmlns:a="http://schemas.openxmlformats.org/drawingml/2006/main"/>
           <a:p xmlns:a="http://schemas.openxmlformats.org/drawingml/2006/main">
             <a:pPr algn="r">
+              <a:buNone/>
               <a:defRPr sz="975" b="1">
                 <a:solidFill>
                   <a:srgbClr val="F7F8F5"/>
@@ -4117,6 +4131,7 @@
           <a:lstStyle xmlns:a="http://schemas.openxmlformats.org/drawingml/2006/main"/>
           <a:p xmlns:a="http://schemas.openxmlformats.org/drawingml/2006/main">
             <a:pPr algn="l">
+              <a:buNone/>
               <a:defRPr sz="1125" b="0">
                 <a:solidFill>
                   <a:srgbClr val="C6D0D3"/>
@@ -4173,6 +4188,7 @@
           <a:lstStyle xmlns:a="http://schemas.openxmlformats.org/drawingml/2006/main"/>
           <a:p xmlns:a="http://schemas.openxmlformats.org/drawingml/2006/main">
             <a:pPr algn="r">
+              <a:buNone/>
               <a:defRPr sz="975" b="1">
                 <a:solidFill>
                   <a:srgbClr val="F7F8F5"/>
@@ -4229,6 +4245,7 @@
           <a:lstStyle xmlns:a="http://schemas.openxmlformats.org/drawingml/2006/main"/>
           <a:p xmlns:a="http://schemas.openxmlformats.org/drawingml/2006/main">
             <a:pPr algn="l">
+              <a:buNone/>
               <a:defRPr sz="825" b="1">
                 <a:solidFill>
                   <a:srgbClr val="83F3C9"/>
@@ -4285,6 +4302,7 @@
           <a:lstStyle xmlns:a="http://schemas.openxmlformats.org/drawingml/2006/main"/>
           <a:p xmlns:a="http://schemas.openxmlformats.org/drawingml/2006/main">
             <a:pPr algn="l">
+              <a:buNone/>
               <a:defRPr sz="1800" b="1">
                 <a:solidFill>
                   <a:srgbClr val="F7F8F5"/>
@@ -4341,6 +4359,7 @@
           <a:lstStyle xmlns:a="http://schemas.openxmlformats.org/drawingml/2006/main"/>
           <a:p xmlns:a="http://schemas.openxmlformats.org/drawingml/2006/main">
             <a:pPr algn="r">
+              <a:buNone/>
               <a:defRPr sz="825" b="1">
                 <a:solidFill>
                   <a:srgbClr val="5F7078"/>
@@ -4457,6 +4476,7 @@
           <a:lstStyle xmlns:a="http://schemas.openxmlformats.org/drawingml/2006/main"/>
           <a:p xmlns:a="http://schemas.openxmlformats.org/drawingml/2006/main">
             <a:pPr algn="l">
+              <a:buNone/>
               <a:defRPr sz="900" b="1">
                 <a:solidFill>
                   <a:srgbClr val="247B63"/>
@@ -4513,6 +4533,7 @@
           <a:lstStyle xmlns:a="http://schemas.openxmlformats.org/drawingml/2006/main"/>
           <a:p xmlns:a="http://schemas.openxmlformats.org/drawingml/2006/main">
             <a:pPr algn="l">
+              <a:buNone/>
               <a:defRPr sz="3300" b="1">
                 <a:solidFill>
                   <a:srgbClr val="0B1720"/>
@@ -4569,6 +4590,7 @@
           <a:lstStyle xmlns:a="http://schemas.openxmlformats.org/drawingml/2006/main"/>
           <a:p xmlns:a="http://schemas.openxmlformats.org/drawingml/2006/main">
             <a:pPr algn="l">
+              <a:buNone/>
               <a:defRPr sz="1350" b="1">
                 <a:solidFill>
                   <a:srgbClr val="247B63"/>
@@ -4660,6 +4682,7 @@
           <a:lstStyle xmlns:a="http://schemas.openxmlformats.org/drawingml/2006/main"/>
           <a:p xmlns:a="http://schemas.openxmlformats.org/drawingml/2006/main">
             <a:pPr algn="ctr">
+              <a:buNone/>
               <a:defRPr sz="975" b="1">
                 <a:solidFill>
                   <a:srgbClr val="51DFE3"/>
@@ -4716,6 +4739,7 @@
           <a:lstStyle xmlns:a="http://schemas.openxmlformats.org/drawingml/2006/main"/>
           <a:p xmlns:a="http://schemas.openxmlformats.org/drawingml/2006/main">
             <a:pPr algn="l">
+              <a:buNone/>
               <a:defRPr sz="825" b="1">
                 <a:solidFill>
                   <a:srgbClr val="51DFE3"/>
@@ -4772,6 +4796,7 @@
           <a:lstStyle xmlns:a="http://schemas.openxmlformats.org/drawingml/2006/main"/>
           <a:p xmlns:a="http://schemas.openxmlformats.org/drawingml/2006/main">
             <a:pPr algn="l">
+              <a:buNone/>
               <a:defRPr sz="1350" b="1">
                 <a:solidFill>
                   <a:srgbClr val="0B1720"/>
@@ -4863,6 +4888,7 @@
           <a:lstStyle xmlns:a="http://schemas.openxmlformats.org/drawingml/2006/main"/>
           <a:p xmlns:a="http://schemas.openxmlformats.org/drawingml/2006/main">
             <a:pPr algn="ctr">
+              <a:buNone/>
               <a:defRPr sz="975" b="1">
                 <a:solidFill>
                   <a:srgbClr val="60D799"/>
@@ -4919,6 +4945,7 @@
           <a:lstStyle xmlns:a="http://schemas.openxmlformats.org/drawingml/2006/main"/>
           <a:p xmlns:a="http://schemas.openxmlformats.org/drawingml/2006/main">
             <a:pPr algn="l">
+              <a:buNone/>
               <a:defRPr sz="825" b="1">
                 <a:solidFill>
                   <a:srgbClr val="60D799"/>
@@ -4975,6 +5002,7 @@
           <a:lstStyle xmlns:a="http://schemas.openxmlformats.org/drawingml/2006/main"/>
           <a:p xmlns:a="http://schemas.openxmlformats.org/drawingml/2006/main">
             <a:pPr algn="l">
+              <a:buNone/>
               <a:defRPr sz="1350" b="1">
                 <a:solidFill>
                   <a:srgbClr val="0B1720"/>
@@ -5066,6 +5094,7 @@
           <a:lstStyle xmlns:a="http://schemas.openxmlformats.org/drawingml/2006/main"/>
           <a:p xmlns:a="http://schemas.openxmlformats.org/drawingml/2006/main">
             <a:pPr algn="ctr">
+              <a:buNone/>
               <a:defRPr sz="975" b="1">
                 <a:solidFill>
                   <a:srgbClr val="F3C668"/>
@@ -5122,6 +5151,7 @@
           <a:lstStyle xmlns:a="http://schemas.openxmlformats.org/drawingml/2006/main"/>
           <a:p xmlns:a="http://schemas.openxmlformats.org/drawingml/2006/main">
             <a:pPr algn="l">
+              <a:buNone/>
               <a:defRPr sz="825" b="1">
                 <a:solidFill>
                   <a:srgbClr val="F3C668"/>
@@ -5178,6 +5208,7 @@
           <a:lstStyle xmlns:a="http://schemas.openxmlformats.org/drawingml/2006/main"/>
           <a:p xmlns:a="http://schemas.openxmlformats.org/drawingml/2006/main">
             <a:pPr algn="l">
+              <a:buNone/>
               <a:defRPr sz="1350" b="1">
                 <a:solidFill>
                   <a:srgbClr val="0B1720"/>
@@ -5269,6 +5300,7 @@
           <a:lstStyle xmlns:a="http://schemas.openxmlformats.org/drawingml/2006/main"/>
           <a:p xmlns:a="http://schemas.openxmlformats.org/drawingml/2006/main">
             <a:pPr algn="ctr">
+              <a:buNone/>
               <a:defRPr sz="975" b="1">
                 <a:solidFill>
                   <a:srgbClr val="AA91FF"/>
@@ -5325,6 +5357,7 @@
           <a:lstStyle xmlns:a="http://schemas.openxmlformats.org/drawingml/2006/main"/>
           <a:p xmlns:a="http://schemas.openxmlformats.org/drawingml/2006/main">
             <a:pPr algn="l">
+              <a:buNone/>
               <a:defRPr sz="825" b="1">
                 <a:solidFill>
                   <a:srgbClr val="AA91FF"/>
@@ -5381,6 +5414,7 @@
           <a:lstStyle xmlns:a="http://schemas.openxmlformats.org/drawingml/2006/main"/>
           <a:p xmlns:a="http://schemas.openxmlformats.org/drawingml/2006/main">
             <a:pPr algn="l">
+              <a:buNone/>
               <a:defRPr sz="1350" b="1">
                 <a:solidFill>
                   <a:srgbClr val="0B1720"/>
@@ -5437,6 +5471,7 @@
           <a:lstStyle xmlns:a="http://schemas.openxmlformats.org/drawingml/2006/main"/>
           <a:p xmlns:a="http://schemas.openxmlformats.org/drawingml/2006/main">
             <a:pPr algn="ctr">
+              <a:buNone/>
               <a:defRPr sz="3150" b="0">
                 <a:solidFill>
                   <a:srgbClr val="5F7078"/>
@@ -5528,6 +5563,7 @@
           <a:lstStyle xmlns:a="http://schemas.openxmlformats.org/drawingml/2006/main"/>
           <a:p xmlns:a="http://schemas.openxmlformats.org/drawingml/2006/main">
             <a:pPr algn="ctr">
+              <a:buNone/>
               <a:defRPr sz="825" b="1">
                 <a:solidFill>
                   <a:srgbClr val="83F3C9"/>
@@ -5584,6 +5620,7 @@
           <a:lstStyle xmlns:a="http://schemas.openxmlformats.org/drawingml/2006/main"/>
           <a:p xmlns:a="http://schemas.openxmlformats.org/drawingml/2006/main">
             <a:pPr algn="ctr">
+              <a:buNone/>
               <a:defRPr sz="2400" b="1">
                 <a:solidFill>
                   <a:srgbClr val="F7F8F5"/>
@@ -5607,6 +5644,7 @@
           </a:p>
           <a:p xmlns:a="http://schemas.openxmlformats.org/drawingml/2006/main">
             <a:pPr algn="ctr">
+              <a:buNone/>
               <a:defRPr sz="2400" b="1">
                 <a:solidFill>
                   <a:srgbClr val="F7F8F5"/>
@@ -5663,6 +5701,7 @@
           <a:lstStyle xmlns:a="http://schemas.openxmlformats.org/drawingml/2006/main"/>
           <a:p xmlns:a="http://schemas.openxmlformats.org/drawingml/2006/main">
             <a:pPr algn="ctr">
+              <a:buNone/>
               <a:defRPr sz="1050" b="0">
                 <a:solidFill>
                   <a:srgbClr val="9AA8AE"/>
@@ -5719,6 +5758,7 @@
           <a:lstStyle xmlns:a="http://schemas.openxmlformats.org/drawingml/2006/main"/>
           <a:p xmlns:a="http://schemas.openxmlformats.org/drawingml/2006/main">
             <a:pPr algn="ctr">
+              <a:buNone/>
               <a:defRPr sz="3150" b="0">
                 <a:solidFill>
                   <a:srgbClr val="5F7078"/>
@@ -5806,6 +5846,7 @@
           <a:lstStyle xmlns:a="http://schemas.openxmlformats.org/drawingml/2006/main"/>
           <a:p xmlns:a="http://schemas.openxmlformats.org/drawingml/2006/main">
             <a:pPr algn="l">
+              <a:buNone/>
               <a:defRPr sz="825" b="1">
                 <a:solidFill>
                   <a:srgbClr val="60D799"/>
@@ -5862,6 +5903,7 @@
           <a:lstStyle xmlns:a="http://schemas.openxmlformats.org/drawingml/2006/main"/>
           <a:p xmlns:a="http://schemas.openxmlformats.org/drawingml/2006/main">
             <a:pPr algn="l">
+              <a:buNone/>
               <a:defRPr sz="1275" b="1">
                 <a:solidFill>
                   <a:srgbClr val="0B1720"/>
@@ -5949,6 +5991,7 @@
           <a:lstStyle xmlns:a="http://schemas.openxmlformats.org/drawingml/2006/main"/>
           <a:p xmlns:a="http://schemas.openxmlformats.org/drawingml/2006/main">
             <a:pPr algn="l">
+              <a:buNone/>
               <a:defRPr sz="825" b="1">
                 <a:solidFill>
                   <a:srgbClr val="60D799"/>
@@ -6005,6 +6048,7 @@
           <a:lstStyle xmlns:a="http://schemas.openxmlformats.org/drawingml/2006/main"/>
           <a:p xmlns:a="http://schemas.openxmlformats.org/drawingml/2006/main">
             <a:pPr algn="l">
+              <a:buNone/>
               <a:defRPr sz="1275" b="1">
                 <a:solidFill>
                   <a:srgbClr val="0B1720"/>
@@ -6092,6 +6136,7 @@
           <a:lstStyle xmlns:a="http://schemas.openxmlformats.org/drawingml/2006/main"/>
           <a:p xmlns:a="http://schemas.openxmlformats.org/drawingml/2006/main">
             <a:pPr algn="l">
+              <a:buNone/>
               <a:defRPr sz="825" b="1">
                 <a:solidFill>
                   <a:srgbClr val="F3C668"/>
@@ -6148,6 +6193,7 @@
           <a:lstStyle xmlns:a="http://schemas.openxmlformats.org/drawingml/2006/main"/>
           <a:p xmlns:a="http://schemas.openxmlformats.org/drawingml/2006/main">
             <a:pPr algn="l">
+              <a:buNone/>
               <a:defRPr sz="1275" b="1">
                 <a:solidFill>
                   <a:srgbClr val="0B1720"/>
@@ -6235,6 +6281,7 @@
           <a:lstStyle xmlns:a="http://schemas.openxmlformats.org/drawingml/2006/main"/>
           <a:p xmlns:a="http://schemas.openxmlformats.org/drawingml/2006/main">
             <a:pPr algn="l">
+              <a:buNone/>
               <a:defRPr sz="825" b="1">
                 <a:solidFill>
                   <a:srgbClr val="F3C668"/>
@@ -6291,6 +6338,7 @@
           <a:lstStyle xmlns:a="http://schemas.openxmlformats.org/drawingml/2006/main"/>
           <a:p xmlns:a="http://schemas.openxmlformats.org/drawingml/2006/main">
             <a:pPr algn="l">
+              <a:buNone/>
               <a:defRPr sz="1275" b="1">
                 <a:solidFill>
                   <a:srgbClr val="0B1720"/>
@@ -6382,6 +6430,7 @@
           <a:lstStyle xmlns:a="http://schemas.openxmlformats.org/drawingml/2006/main"/>
           <a:p xmlns:a="http://schemas.openxmlformats.org/drawingml/2006/main">
             <a:pPr algn="ctr">
+              <a:buNone/>
               <a:defRPr sz="1425" b="1">
                 <a:solidFill>
                   <a:srgbClr val="0B1720"/>
@@ -6438,6 +6487,7 @@
           <a:lstStyle xmlns:a="http://schemas.openxmlformats.org/drawingml/2006/main"/>
           <a:p xmlns:a="http://schemas.openxmlformats.org/drawingml/2006/main">
             <a:pPr algn="r">
+              <a:buNone/>
               <a:defRPr sz="825" b="1">
                 <a:solidFill>
                   <a:srgbClr val="5F7078"/>
@@ -6554,6 +6604,7 @@
           <a:lstStyle xmlns:a="http://schemas.openxmlformats.org/drawingml/2006/main"/>
           <a:p xmlns:a="http://schemas.openxmlformats.org/drawingml/2006/main">
             <a:pPr algn="l">
+              <a:buNone/>
               <a:defRPr sz="900" b="1">
                 <a:solidFill>
                   <a:srgbClr val="83F3C9"/>
@@ -6610,6 +6661,7 @@
           <a:lstStyle xmlns:a="http://schemas.openxmlformats.org/drawingml/2006/main"/>
           <a:p xmlns:a="http://schemas.openxmlformats.org/drawingml/2006/main">
             <a:pPr algn="l">
+              <a:buNone/>
               <a:defRPr sz="3900" b="1">
                 <a:solidFill>
                   <a:srgbClr val="F7F8F5"/>
@@ -6666,6 +6718,7 @@
           <a:lstStyle xmlns:a="http://schemas.openxmlformats.org/drawingml/2006/main"/>
           <a:p xmlns:a="http://schemas.openxmlformats.org/drawingml/2006/main">
             <a:pPr algn="l">
+              <a:buNone/>
               <a:defRPr sz="1425" b="0">
                 <a:solidFill>
                   <a:srgbClr val="9AA8AE"/>
@@ -6722,6 +6775,7 @@
           <a:lstStyle xmlns:a="http://schemas.openxmlformats.org/drawingml/2006/main"/>
           <a:p xmlns:a="http://schemas.openxmlformats.org/drawingml/2006/main">
             <a:pPr algn="l">
+              <a:buNone/>
               <a:defRPr sz="2400" b="1">
                 <a:solidFill>
                   <a:srgbClr val="83F3C9"/>
@@ -6778,6 +6832,7 @@
           <a:lstStyle xmlns:a="http://schemas.openxmlformats.org/drawingml/2006/main"/>
           <a:p xmlns:a="http://schemas.openxmlformats.org/drawingml/2006/main">
             <a:pPr algn="l">
+              <a:buNone/>
               <a:defRPr sz="1125" b="0">
                 <a:solidFill>
                   <a:srgbClr val="9AA8AE"/>
@@ -6834,6 +6889,7 @@
           <a:lstStyle xmlns:a="http://schemas.openxmlformats.org/drawingml/2006/main"/>
           <a:p xmlns:a="http://schemas.openxmlformats.org/drawingml/2006/main">
             <a:pPr algn="l">
+              <a:buNone/>
               <a:defRPr sz="2400" b="1">
                 <a:solidFill>
                   <a:srgbClr val="83F3C9"/>
@@ -6890,6 +6946,7 @@
           <a:lstStyle xmlns:a="http://schemas.openxmlformats.org/drawingml/2006/main"/>
           <a:p xmlns:a="http://schemas.openxmlformats.org/drawingml/2006/main">
             <a:pPr algn="l">
+              <a:buNone/>
               <a:defRPr sz="1125" b="0">
                 <a:solidFill>
                   <a:srgbClr val="9AA8AE"/>
@@ -6946,6 +7003,7 @@
           <a:lstStyle xmlns:a="http://schemas.openxmlformats.org/drawingml/2006/main"/>
           <a:p xmlns:a="http://schemas.openxmlformats.org/drawingml/2006/main">
             <a:pPr algn="l">
+              <a:buNone/>
               <a:defRPr sz="2400" b="1">
                 <a:solidFill>
                   <a:srgbClr val="83F3C9"/>
@@ -7002,6 +7060,7 @@
           <a:lstStyle xmlns:a="http://schemas.openxmlformats.org/drawingml/2006/main"/>
           <a:p xmlns:a="http://schemas.openxmlformats.org/drawingml/2006/main">
             <a:pPr algn="l">
+              <a:buNone/>
               <a:defRPr sz="1125" b="0">
                 <a:solidFill>
                   <a:srgbClr val="9AA8AE"/>
@@ -7058,6 +7117,7 @@
           <a:lstStyle xmlns:a="http://schemas.openxmlformats.org/drawingml/2006/main"/>
           <a:p xmlns:a="http://schemas.openxmlformats.org/drawingml/2006/main">
             <a:pPr algn="l">
+              <a:buNone/>
               <a:defRPr sz="2400" b="1">
                 <a:solidFill>
                   <a:srgbClr val="83F3C9"/>
@@ -7114,6 +7174,7 @@
           <a:lstStyle xmlns:a="http://schemas.openxmlformats.org/drawingml/2006/main"/>
           <a:p xmlns:a="http://schemas.openxmlformats.org/drawingml/2006/main">
             <a:pPr algn="l">
+              <a:buNone/>
               <a:defRPr sz="1125" b="0">
                 <a:solidFill>
                   <a:srgbClr val="9AA8AE"/>
@@ -7205,6 +7266,7 @@
           <a:lstStyle xmlns:a="http://schemas.openxmlformats.org/drawingml/2006/main"/>
           <a:p xmlns:a="http://schemas.openxmlformats.org/drawingml/2006/main">
             <a:pPr algn="ctr">
+              <a:buNone/>
               <a:defRPr sz="750" b="1">
                 <a:solidFill>
                   <a:srgbClr val="F3C668"/>
@@ -7261,6 +7323,7 @@
           <a:lstStyle xmlns:a="http://schemas.openxmlformats.org/drawingml/2006/main"/>
           <a:p xmlns:a="http://schemas.openxmlformats.org/drawingml/2006/main">
             <a:pPr algn="l">
+              <a:buNone/>
               <a:defRPr sz="675" b="0">
                 <a:solidFill>
                   <a:srgbClr val="5F7078"/>
@@ -7317,6 +7380,7 @@
           <a:lstStyle xmlns:a="http://schemas.openxmlformats.org/drawingml/2006/main"/>
           <a:p xmlns:a="http://schemas.openxmlformats.org/drawingml/2006/main">
             <a:pPr algn="r">
+              <a:buNone/>
               <a:defRPr sz="825" b="1">
                 <a:solidFill>
                   <a:srgbClr val="5F7078"/>
@@ -7349,7 +7413,7 @@
           <p:nvPr/>
         </p:nvPicPr>
         <p:blipFill>
-          <a:blip xmlns:r="http://schemas.openxmlformats.org/officeDocument/2006/relationships" xmlns:a="http://schemas.openxmlformats.org/drawingml/2006/main" r:embed="Rff50221032b24282"/>
+          <a:blip xmlns:r="http://schemas.openxmlformats.org/officeDocument/2006/relationships" xmlns:a="http://schemas.openxmlformats.org/drawingml/2006/main" r:embed="Ra0acc80a9f2d49da"/>
           <a:srcRect xmlns:a="http://schemas.openxmlformats.org/drawingml/2006/main" l="19" t="0" r="19" b="0"/>
           <a:stretch xmlns:a="http://schemas.openxmlformats.org/drawingml/2006/main">
             <a:fillRect l="0" t="0" r="0" b="0"/>
@@ -7460,6 +7524,7 @@
           <a:lstStyle xmlns:a="http://schemas.openxmlformats.org/drawingml/2006/main"/>
           <a:p xmlns:a="http://schemas.openxmlformats.org/drawingml/2006/main">
             <a:pPr algn="l">
+              <a:buNone/>
               <a:defRPr sz="900" b="1">
                 <a:solidFill>
                   <a:srgbClr val="247B63"/>
@@ -7516,6 +7581,7 @@
           <a:lstStyle xmlns:a="http://schemas.openxmlformats.org/drawingml/2006/main"/>
           <a:p xmlns:a="http://schemas.openxmlformats.org/drawingml/2006/main">
             <a:pPr algn="l">
+              <a:buNone/>
               <a:defRPr sz="3150" b="1">
                 <a:solidFill>
                   <a:srgbClr val="0B1720"/>
@@ -7572,6 +7638,7 @@
           <a:lstStyle xmlns:a="http://schemas.openxmlformats.org/drawingml/2006/main"/>
           <a:p xmlns:a="http://schemas.openxmlformats.org/drawingml/2006/main">
             <a:pPr algn="l">
+              <a:buNone/>
               <a:defRPr sz="1425" b="0">
                 <a:solidFill>
                   <a:srgbClr val="5F7078"/>
@@ -7659,6 +7726,7 @@
           <a:lstStyle xmlns:a="http://schemas.openxmlformats.org/drawingml/2006/main"/>
           <a:p xmlns:a="http://schemas.openxmlformats.org/drawingml/2006/main">
             <a:pPr algn="l">
+              <a:buNone/>
               <a:defRPr sz="825" b="1">
                 <a:solidFill>
                   <a:srgbClr val="247B63"/>
@@ -7715,6 +7783,7 @@
           <a:lstStyle xmlns:a="http://schemas.openxmlformats.org/drawingml/2006/main"/>
           <a:p xmlns:a="http://schemas.openxmlformats.org/drawingml/2006/main">
             <a:pPr algn="l">
+              <a:buNone/>
               <a:defRPr sz="5100" b="1">
                 <a:solidFill>
                   <a:srgbClr val="0B1720"/>
@@ -7771,6 +7840,7 @@
           <a:lstStyle xmlns:a="http://schemas.openxmlformats.org/drawingml/2006/main"/>
           <a:p xmlns:a="http://schemas.openxmlformats.org/drawingml/2006/main">
             <a:pPr algn="l">
+              <a:buNone/>
               <a:defRPr sz="1650" b="0">
                 <a:solidFill>
                   <a:srgbClr val="5F7078"/>
@@ -7827,6 +7897,7 @@
           <a:lstStyle xmlns:a="http://schemas.openxmlformats.org/drawingml/2006/main"/>
           <a:p xmlns:a="http://schemas.openxmlformats.org/drawingml/2006/main">
             <a:pPr algn="l">
+              <a:buNone/>
               <a:defRPr sz="1500" b="1">
                 <a:solidFill>
                   <a:srgbClr val="0B1720"/>
@@ -7918,6 +7989,7 @@
           <a:lstStyle xmlns:a="http://schemas.openxmlformats.org/drawingml/2006/main"/>
           <a:p xmlns:a="http://schemas.openxmlformats.org/drawingml/2006/main">
             <a:pPr algn="ctr">
+              <a:buNone/>
               <a:defRPr sz="750" b="1">
                 <a:solidFill>
                   <a:srgbClr val="5F7078"/>
@@ -7974,6 +8046,7 @@
           <a:lstStyle xmlns:a="http://schemas.openxmlformats.org/drawingml/2006/main"/>
           <a:p xmlns:a="http://schemas.openxmlformats.org/drawingml/2006/main">
             <a:pPr algn="l">
+              <a:buNone/>
               <a:defRPr sz="825" b="1">
                 <a:solidFill>
                   <a:srgbClr val="247B63"/>
@@ -8030,6 +8103,7 @@
           <a:lstStyle xmlns:a="http://schemas.openxmlformats.org/drawingml/2006/main"/>
           <a:p xmlns:a="http://schemas.openxmlformats.org/drawingml/2006/main">
             <a:pPr algn="l">
+              <a:buNone/>
               <a:defRPr sz="5100" b="1">
                 <a:solidFill>
                   <a:srgbClr val="0B1720"/>
@@ -8086,6 +8160,7 @@
           <a:lstStyle xmlns:a="http://schemas.openxmlformats.org/drawingml/2006/main"/>
           <a:p xmlns:a="http://schemas.openxmlformats.org/drawingml/2006/main">
             <a:pPr algn="l">
+              <a:buNone/>
               <a:defRPr sz="1650" b="0">
                 <a:solidFill>
                   <a:srgbClr val="5F7078"/>
@@ -8142,6 +8217,7 @@
           <a:lstStyle xmlns:a="http://schemas.openxmlformats.org/drawingml/2006/main"/>
           <a:p xmlns:a="http://schemas.openxmlformats.org/drawingml/2006/main">
             <a:pPr algn="l">
+              <a:buNone/>
               <a:defRPr sz="1500" b="1">
                 <a:solidFill>
                   <a:srgbClr val="0B1720"/>
@@ -8233,6 +8309,7 @@
           <a:lstStyle xmlns:a="http://schemas.openxmlformats.org/drawingml/2006/main"/>
           <a:p xmlns:a="http://schemas.openxmlformats.org/drawingml/2006/main">
             <a:pPr algn="ctr">
+              <a:buNone/>
               <a:defRPr sz="750" b="1">
                 <a:solidFill>
                   <a:srgbClr val="5F7078"/>
@@ -8324,6 +8401,7 @@
           <a:lstStyle xmlns:a="http://schemas.openxmlformats.org/drawingml/2006/main"/>
           <a:p xmlns:a="http://schemas.openxmlformats.org/drawingml/2006/main">
             <a:pPr algn="ctr">
+              <a:buNone/>
               <a:defRPr sz="1125" b="1">
                 <a:solidFill>
                   <a:srgbClr val="F7F8F5"/>
@@ -8380,6 +8458,7 @@
           <a:lstStyle xmlns:a="http://schemas.openxmlformats.org/drawingml/2006/main"/>
           <a:p xmlns:a="http://schemas.openxmlformats.org/drawingml/2006/main">
             <a:pPr algn="l">
+              <a:buNone/>
               <a:defRPr sz="675" b="0">
                 <a:solidFill>
                   <a:srgbClr val="5F7078"/>
@@ -8436,6 +8515,7 @@
           <a:lstStyle xmlns:a="http://schemas.openxmlformats.org/drawingml/2006/main"/>
           <a:p xmlns:a="http://schemas.openxmlformats.org/drawingml/2006/main">
             <a:pPr algn="r">
+              <a:buNone/>
               <a:defRPr sz="825" b="1">
                 <a:solidFill>
                   <a:srgbClr val="5F7078"/>
@@ -9482,6 +9562,7 @@
           <a:lstStyle xmlns:a="http://schemas.openxmlformats.org/drawingml/2006/main"/>
           <a:p xmlns:a="http://schemas.openxmlformats.org/drawingml/2006/main">
             <a:pPr algn="l">
+              <a:buNone/>
               <a:defRPr sz="900" b="1">
                 <a:solidFill>
                   <a:srgbClr val="83F3C9"/>
@@ -9538,6 +9619,7 @@
           <a:lstStyle xmlns:a="http://schemas.openxmlformats.org/drawingml/2006/main"/>
           <a:p xmlns:a="http://schemas.openxmlformats.org/drawingml/2006/main">
             <a:pPr algn="l">
+              <a:buNone/>
               <a:defRPr sz="3300" b="1">
                 <a:solidFill>
                   <a:srgbClr val="F7F8F5"/>
@@ -9594,6 +9676,7 @@
           <a:lstStyle xmlns:a="http://schemas.openxmlformats.org/drawingml/2006/main"/>
           <a:p xmlns:a="http://schemas.openxmlformats.org/drawingml/2006/main">
             <a:pPr algn="l">
+              <a:buNone/>
               <a:defRPr sz="1500" b="0">
                 <a:solidFill>
                   <a:srgbClr val="9AA8AE"/>
@@ -10244,6 +10327,7 @@
           <a:lstStyle xmlns:a="http://schemas.openxmlformats.org/drawingml/2006/main"/>
           <a:p xmlns:a="http://schemas.openxmlformats.org/drawingml/2006/main">
             <a:pPr algn="ctr">
+              <a:buNone/>
               <a:defRPr sz="825" b="1">
                 <a:solidFill>
                   <a:srgbClr val="9AA8AE"/>
@@ -10300,6 +10384,7 @@
           <a:lstStyle xmlns:a="http://schemas.openxmlformats.org/drawingml/2006/main"/>
           <a:p xmlns:a="http://schemas.openxmlformats.org/drawingml/2006/main">
             <a:pPr algn="ctr">
+              <a:buNone/>
               <a:defRPr sz="3150" b="0">
                 <a:solidFill>
                   <a:srgbClr val="9AA8AE"/>
@@ -10391,6 +10476,7 @@
           <a:lstStyle xmlns:a="http://schemas.openxmlformats.org/drawingml/2006/main"/>
           <a:p xmlns:a="http://schemas.openxmlformats.org/drawingml/2006/main">
             <a:pPr algn="l">
+              <a:buNone/>
               <a:defRPr sz="825" b="1">
                 <a:solidFill>
                   <a:srgbClr val="9AA8AE"/>
@@ -10478,6 +10564,7 @@
           <a:lstStyle xmlns:a="http://schemas.openxmlformats.org/drawingml/2006/main"/>
           <a:p xmlns:a="http://schemas.openxmlformats.org/drawingml/2006/main">
             <a:pPr algn="ctr">
+              <a:buNone/>
               <a:defRPr sz="975" b="1">
                 <a:solidFill>
                   <a:srgbClr val="FF7487"/>
@@ -10534,6 +10621,7 @@
           <a:lstStyle xmlns:a="http://schemas.openxmlformats.org/drawingml/2006/main"/>
           <a:p xmlns:a="http://schemas.openxmlformats.org/drawingml/2006/main">
             <a:pPr algn="ctr">
+              <a:buNone/>
               <a:defRPr sz="1650" b="1">
                 <a:solidFill>
                   <a:srgbClr val="83F3C9"/>
@@ -10590,6 +10678,7 @@
           <a:lstStyle xmlns:a="http://schemas.openxmlformats.org/drawingml/2006/main"/>
           <a:p xmlns:a="http://schemas.openxmlformats.org/drawingml/2006/main">
             <a:pPr algn="l">
+              <a:buNone/>
               <a:defRPr sz="675" b="0">
                 <a:solidFill>
                   <a:srgbClr val="5F7078"/>
@@ -10646,6 +10735,7 @@
           <a:lstStyle xmlns:a="http://schemas.openxmlformats.org/drawingml/2006/main"/>
           <a:p xmlns:a="http://schemas.openxmlformats.org/drawingml/2006/main">
             <a:pPr algn="r">
+              <a:buNone/>
               <a:defRPr sz="825" b="1">
                 <a:solidFill>
                   <a:srgbClr val="5F7078"/>
@@ -10762,6 +10852,7 @@
           <a:lstStyle xmlns:a="http://schemas.openxmlformats.org/drawingml/2006/main"/>
           <a:p xmlns:a="http://schemas.openxmlformats.org/drawingml/2006/main">
             <a:pPr algn="l">
+              <a:buNone/>
               <a:defRPr sz="900" b="1">
                 <a:solidFill>
                   <a:srgbClr val="247B63"/>
@@ -10818,6 +10909,7 @@
           <a:lstStyle xmlns:a="http://schemas.openxmlformats.org/drawingml/2006/main"/>
           <a:p xmlns:a="http://schemas.openxmlformats.org/drawingml/2006/main">
             <a:pPr algn="l">
+              <a:buNone/>
               <a:defRPr sz="3300" b="1">
                 <a:solidFill>
                   <a:srgbClr val="0B1720"/>
@@ -10874,6 +10966,7 @@
           <a:lstStyle xmlns:a="http://schemas.openxmlformats.org/drawingml/2006/main"/>
           <a:p xmlns:a="http://schemas.openxmlformats.org/drawingml/2006/main">
             <a:pPr algn="l">
+              <a:buNone/>
               <a:defRPr sz="1575" b="0">
                 <a:solidFill>
                   <a:srgbClr val="5F7078"/>
@@ -10930,6 +11023,7 @@
           <a:lstStyle xmlns:a="http://schemas.openxmlformats.org/drawingml/2006/main"/>
           <a:p xmlns:a="http://schemas.openxmlformats.org/drawingml/2006/main">
             <a:pPr algn="r">
+              <a:buNone/>
               <a:defRPr sz="825" b="1">
                 <a:solidFill>
                   <a:srgbClr val="FF7487"/>
@@ -11021,6 +11115,7 @@
           <a:lstStyle xmlns:a="http://schemas.openxmlformats.org/drawingml/2006/main"/>
           <a:p xmlns:a="http://schemas.openxmlformats.org/drawingml/2006/main">
             <a:pPr algn="l">
+              <a:buNone/>
               <a:defRPr sz="825" b="1">
                 <a:solidFill>
                   <a:srgbClr val="7AA7FF"/>
@@ -11077,6 +11172,7 @@
           <a:lstStyle xmlns:a="http://schemas.openxmlformats.org/drawingml/2006/main"/>
           <a:p xmlns:a="http://schemas.openxmlformats.org/drawingml/2006/main">
             <a:pPr algn="l">
+              <a:buNone/>
               <a:defRPr sz="1350" b="1">
                 <a:solidFill>
                   <a:srgbClr val="0B1720"/>
@@ -11133,6 +11229,7 @@
           <a:lstStyle xmlns:a="http://schemas.openxmlformats.org/drawingml/2006/main"/>
           <a:p xmlns:a="http://schemas.openxmlformats.org/drawingml/2006/main">
             <a:pPr algn="l">
+              <a:buNone/>
               <a:defRPr sz="900" b="0">
                 <a:solidFill>
                   <a:srgbClr val="5F7078"/>
@@ -11224,6 +11321,7 @@
           <a:lstStyle xmlns:a="http://schemas.openxmlformats.org/drawingml/2006/main"/>
           <a:p xmlns:a="http://schemas.openxmlformats.org/drawingml/2006/main">
             <a:pPr algn="l">
+              <a:buNone/>
               <a:defRPr sz="825" b="1">
                 <a:solidFill>
                   <a:srgbClr val="51DFE3"/>
@@ -11280,6 +11378,7 @@
           <a:lstStyle xmlns:a="http://schemas.openxmlformats.org/drawingml/2006/main"/>
           <a:p xmlns:a="http://schemas.openxmlformats.org/drawingml/2006/main">
             <a:pPr algn="l">
+              <a:buNone/>
               <a:defRPr sz="1350" b="1">
                 <a:solidFill>
                   <a:srgbClr val="0B1720"/>
@@ -11336,6 +11435,7 @@
           <a:lstStyle xmlns:a="http://schemas.openxmlformats.org/drawingml/2006/main"/>
           <a:p xmlns:a="http://schemas.openxmlformats.org/drawingml/2006/main">
             <a:pPr algn="l">
+              <a:buNone/>
               <a:defRPr sz="900" b="0">
                 <a:solidFill>
                   <a:srgbClr val="5F7078"/>
@@ -11427,6 +11527,7 @@
           <a:lstStyle xmlns:a="http://schemas.openxmlformats.org/drawingml/2006/main"/>
           <a:p xmlns:a="http://schemas.openxmlformats.org/drawingml/2006/main">
             <a:pPr algn="l">
+              <a:buNone/>
               <a:defRPr sz="825" b="1">
                 <a:solidFill>
                   <a:srgbClr val="60D799"/>
@@ -11483,6 +11584,7 @@
           <a:lstStyle xmlns:a="http://schemas.openxmlformats.org/drawingml/2006/main"/>
           <a:p xmlns:a="http://schemas.openxmlformats.org/drawingml/2006/main">
             <a:pPr algn="l">
+              <a:buNone/>
               <a:defRPr sz="1350" b="1">
                 <a:solidFill>
                   <a:srgbClr val="0B1720"/>
@@ -11539,6 +11641,7 @@
           <a:lstStyle xmlns:a="http://schemas.openxmlformats.org/drawingml/2006/main"/>
           <a:p xmlns:a="http://schemas.openxmlformats.org/drawingml/2006/main">
             <a:pPr algn="l">
+              <a:buNone/>
               <a:defRPr sz="900" b="0">
                 <a:solidFill>
                   <a:srgbClr val="5F7078"/>
@@ -11630,6 +11733,7 @@
           <a:lstStyle xmlns:a="http://schemas.openxmlformats.org/drawingml/2006/main"/>
           <a:p xmlns:a="http://schemas.openxmlformats.org/drawingml/2006/main">
             <a:pPr algn="l">
+              <a:buNone/>
               <a:defRPr sz="825" b="1">
                 <a:solidFill>
                   <a:srgbClr val="F3C668"/>
@@ -11686,6 +11790,7 @@
           <a:lstStyle xmlns:a="http://schemas.openxmlformats.org/drawingml/2006/main"/>
           <a:p xmlns:a="http://schemas.openxmlformats.org/drawingml/2006/main">
             <a:pPr algn="l">
+              <a:buNone/>
               <a:defRPr sz="1350" b="1">
                 <a:solidFill>
                   <a:srgbClr val="0B1720"/>
@@ -11742,6 +11847,7 @@
           <a:lstStyle xmlns:a="http://schemas.openxmlformats.org/drawingml/2006/main"/>
           <a:p xmlns:a="http://schemas.openxmlformats.org/drawingml/2006/main">
             <a:pPr algn="l">
+              <a:buNone/>
               <a:defRPr sz="900" b="0">
                 <a:solidFill>
                   <a:srgbClr val="5F7078"/>
@@ -11833,6 +11939,7 @@
           <a:lstStyle xmlns:a="http://schemas.openxmlformats.org/drawingml/2006/main"/>
           <a:p xmlns:a="http://schemas.openxmlformats.org/drawingml/2006/main">
             <a:pPr algn="l">
+              <a:buNone/>
               <a:defRPr sz="825" b="1">
                 <a:solidFill>
                   <a:srgbClr val="FF7487"/>
@@ -11889,6 +11996,7 @@
           <a:lstStyle xmlns:a="http://schemas.openxmlformats.org/drawingml/2006/main"/>
           <a:p xmlns:a="http://schemas.openxmlformats.org/drawingml/2006/main">
             <a:pPr algn="l">
+              <a:buNone/>
               <a:defRPr sz="1200" b="1">
                 <a:solidFill>
                   <a:srgbClr val="0B1720"/>
@@ -11945,6 +12053,7 @@
           <a:lstStyle xmlns:a="http://schemas.openxmlformats.org/drawingml/2006/main"/>
           <a:p xmlns:a="http://schemas.openxmlformats.org/drawingml/2006/main">
             <a:pPr algn="l">
+              <a:buNone/>
               <a:defRPr sz="900" b="0">
                 <a:solidFill>
                   <a:srgbClr val="5F7078"/>
@@ -12032,6 +12141,7 @@
           <a:lstStyle xmlns:a="http://schemas.openxmlformats.org/drawingml/2006/main"/>
           <a:p xmlns:a="http://schemas.openxmlformats.org/drawingml/2006/main">
             <a:pPr algn="ctr">
+              <a:buNone/>
               <a:defRPr sz="900" b="1">
                 <a:solidFill>
                   <a:srgbClr val="247B63"/>
@@ -12123,6 +12233,7 @@
           <a:lstStyle xmlns:a="http://schemas.openxmlformats.org/drawingml/2006/main"/>
           <a:p xmlns:a="http://schemas.openxmlformats.org/drawingml/2006/main">
             <a:pPr algn="ctr">
+              <a:buNone/>
               <a:defRPr sz="900" b="1">
                 <a:solidFill>
                   <a:srgbClr val="83F3C9"/>
@@ -12179,6 +12290,7 @@
           <a:lstStyle xmlns:a="http://schemas.openxmlformats.org/drawingml/2006/main"/>
           <a:p xmlns:a="http://schemas.openxmlformats.org/drawingml/2006/main">
             <a:pPr algn="r">
+              <a:buNone/>
               <a:defRPr sz="825" b="1">
                 <a:solidFill>
                   <a:srgbClr val="5F7078"/>
@@ -13225,6 +13337,7 @@
           <a:lstStyle xmlns:a="http://schemas.openxmlformats.org/drawingml/2006/main"/>
           <a:p xmlns:a="http://schemas.openxmlformats.org/drawingml/2006/main">
             <a:pPr algn="l">
+              <a:buNone/>
               <a:defRPr sz="900" b="1">
                 <a:solidFill>
                   <a:srgbClr val="83F3C9"/>
@@ -13281,6 +13394,7 @@
           <a:lstStyle xmlns:a="http://schemas.openxmlformats.org/drawingml/2006/main"/>
           <a:p xmlns:a="http://schemas.openxmlformats.org/drawingml/2006/main">
             <a:pPr algn="l">
+              <a:buNone/>
               <a:defRPr sz="3750" b="1">
                 <a:solidFill>
                   <a:srgbClr val="F7F8F5"/>
@@ -13337,6 +13451,7 @@
           <a:lstStyle xmlns:a="http://schemas.openxmlformats.org/drawingml/2006/main"/>
           <a:p xmlns:a="http://schemas.openxmlformats.org/drawingml/2006/main">
             <a:pPr algn="l">
+              <a:buNone/>
               <a:defRPr sz="1575" b="0">
                 <a:solidFill>
                   <a:srgbClr val="83F3C9"/>
@@ -13393,6 +13508,7 @@
           <a:lstStyle xmlns:a="http://schemas.openxmlformats.org/drawingml/2006/main"/>
           <a:p xmlns:a="http://schemas.openxmlformats.org/drawingml/2006/main">
             <a:pPr algn="l">
+              <a:buNone/>
               <a:defRPr sz="825" b="1">
                 <a:solidFill>
                   <a:srgbClr val="7AA7FF"/>
@@ -13449,6 +13565,7 @@
           <a:lstStyle xmlns:a="http://schemas.openxmlformats.org/drawingml/2006/main"/>
           <a:p xmlns:a="http://schemas.openxmlformats.org/drawingml/2006/main">
             <a:pPr algn="l">
+              <a:buNone/>
               <a:defRPr sz="2550" b="1">
                 <a:solidFill>
                   <a:srgbClr val="F7F8F5"/>
@@ -13536,6 +13653,7 @@
           <a:lstStyle xmlns:a="http://schemas.openxmlformats.org/drawingml/2006/main"/>
           <a:p xmlns:a="http://schemas.openxmlformats.org/drawingml/2006/main">
             <a:pPr algn="l">
+              <a:buNone/>
               <a:defRPr sz="1500" b="0">
                 <a:solidFill>
                   <a:srgbClr val="C4D0D3"/>
@@ -13559,6 +13677,7 @@
           </a:p>
           <a:p xmlns:a="http://schemas.openxmlformats.org/drawingml/2006/main">
             <a:pPr algn="l">
+              <a:buNone/>
               <a:defRPr sz="1500" b="0">
                 <a:solidFill>
                   <a:srgbClr val="C4D0D3"/>
@@ -13582,6 +13701,7 @@
           </a:p>
           <a:p xmlns:a="http://schemas.openxmlformats.org/drawingml/2006/main">
             <a:pPr algn="l">
+              <a:buNone/>
               <a:defRPr sz="1500" b="0">
                 <a:solidFill>
                   <a:srgbClr val="C4D0D3"/>
@@ -13638,6 +13758,7 @@
           <a:lstStyle xmlns:a="http://schemas.openxmlformats.org/drawingml/2006/main"/>
           <a:p xmlns:a="http://schemas.openxmlformats.org/drawingml/2006/main">
             <a:pPr algn="ctr">
+              <a:buNone/>
               <a:defRPr sz="2100" b="0">
                 <a:solidFill>
                   <a:srgbClr val="9AA8AE"/>
@@ -13694,6 +13815,7 @@
           <a:lstStyle xmlns:a="http://schemas.openxmlformats.org/drawingml/2006/main"/>
           <a:p xmlns:a="http://schemas.openxmlformats.org/drawingml/2006/main">
             <a:pPr algn="l">
+              <a:buNone/>
               <a:defRPr sz="825" b="1">
                 <a:solidFill>
                   <a:srgbClr val="51DFE3"/>
@@ -13750,6 +13872,7 @@
           <a:lstStyle xmlns:a="http://schemas.openxmlformats.org/drawingml/2006/main"/>
           <a:p xmlns:a="http://schemas.openxmlformats.org/drawingml/2006/main">
             <a:pPr algn="l">
+              <a:buNone/>
               <a:defRPr sz="2550" b="1">
                 <a:solidFill>
                   <a:srgbClr val="F7F8F5"/>
@@ -13837,6 +13960,7 @@
           <a:lstStyle xmlns:a="http://schemas.openxmlformats.org/drawingml/2006/main"/>
           <a:p xmlns:a="http://schemas.openxmlformats.org/drawingml/2006/main">
             <a:pPr algn="l">
+              <a:buNone/>
               <a:defRPr sz="1500" b="0">
                 <a:solidFill>
                   <a:srgbClr val="C4D0D3"/>
@@ -13860,6 +13984,7 @@
           </a:p>
           <a:p xmlns:a="http://schemas.openxmlformats.org/drawingml/2006/main">
             <a:pPr algn="l">
+              <a:buNone/>
               <a:defRPr sz="1500" b="0">
                 <a:solidFill>
                   <a:srgbClr val="C4D0D3"/>
@@ -13883,6 +14008,7 @@
           </a:p>
           <a:p xmlns:a="http://schemas.openxmlformats.org/drawingml/2006/main">
             <a:pPr algn="l">
+              <a:buNone/>
               <a:defRPr sz="1500" b="0">
                 <a:solidFill>
                   <a:srgbClr val="C4D0D3"/>
@@ -13939,6 +14065,7 @@
           <a:lstStyle xmlns:a="http://schemas.openxmlformats.org/drawingml/2006/main"/>
           <a:p xmlns:a="http://schemas.openxmlformats.org/drawingml/2006/main">
             <a:pPr algn="ctr">
+              <a:buNone/>
               <a:defRPr sz="2100" b="0">
                 <a:solidFill>
                   <a:srgbClr val="9AA8AE"/>
@@ -13995,6 +14122,7 @@
           <a:lstStyle xmlns:a="http://schemas.openxmlformats.org/drawingml/2006/main"/>
           <a:p xmlns:a="http://schemas.openxmlformats.org/drawingml/2006/main">
             <a:pPr algn="l">
+              <a:buNone/>
               <a:defRPr sz="825" b="1">
                 <a:solidFill>
                   <a:srgbClr val="83F3C9"/>
@@ -14051,6 +14179,7 @@
           <a:lstStyle xmlns:a="http://schemas.openxmlformats.org/drawingml/2006/main"/>
           <a:p xmlns:a="http://schemas.openxmlformats.org/drawingml/2006/main">
             <a:pPr algn="l">
+              <a:buNone/>
               <a:defRPr sz="2550" b="1">
                 <a:solidFill>
                   <a:srgbClr val="F7F8F5"/>
@@ -14138,6 +14267,7 @@
           <a:lstStyle xmlns:a="http://schemas.openxmlformats.org/drawingml/2006/main"/>
           <a:p xmlns:a="http://schemas.openxmlformats.org/drawingml/2006/main">
             <a:pPr algn="l">
+              <a:buNone/>
               <a:defRPr sz="1500" b="0">
                 <a:solidFill>
                   <a:srgbClr val="C4D0D3"/>
@@ -14161,6 +14291,7 @@
           </a:p>
           <a:p xmlns:a="http://schemas.openxmlformats.org/drawingml/2006/main">
             <a:pPr algn="l">
+              <a:buNone/>
               <a:defRPr sz="1500" b="0">
                 <a:solidFill>
                   <a:srgbClr val="C4D0D3"/>
@@ -14184,6 +14315,7 @@
           </a:p>
           <a:p xmlns:a="http://schemas.openxmlformats.org/drawingml/2006/main">
             <a:pPr algn="l">
+              <a:buNone/>
               <a:defRPr sz="1500" b="0">
                 <a:solidFill>
                   <a:srgbClr val="C4D0D3"/>
@@ -14240,6 +14372,7 @@
           <a:lstStyle xmlns:a="http://schemas.openxmlformats.org/drawingml/2006/main"/>
           <a:p xmlns:a="http://schemas.openxmlformats.org/drawingml/2006/main">
             <a:pPr algn="l">
+              <a:buNone/>
               <a:defRPr sz="825" b="1">
                 <a:solidFill>
                   <a:srgbClr val="83F3C9"/>
@@ -14331,6 +14464,7 @@
           <a:lstStyle xmlns:a="http://schemas.openxmlformats.org/drawingml/2006/main"/>
           <a:p xmlns:a="http://schemas.openxmlformats.org/drawingml/2006/main">
             <a:pPr algn="ctr">
+              <a:buNone/>
               <a:defRPr sz="825" b="1">
                 <a:solidFill>
                   <a:srgbClr val="F7F8F5"/>
@@ -14422,6 +14556,7 @@
           <a:lstStyle xmlns:a="http://schemas.openxmlformats.org/drawingml/2006/main"/>
           <a:p xmlns:a="http://schemas.openxmlformats.org/drawingml/2006/main">
             <a:pPr algn="ctr">
+              <a:buNone/>
               <a:defRPr sz="825" b="1">
                 <a:solidFill>
                   <a:srgbClr val="F7F8F5"/>
@@ -14513,6 +14648,7 @@
           <a:lstStyle xmlns:a="http://schemas.openxmlformats.org/drawingml/2006/main"/>
           <a:p xmlns:a="http://schemas.openxmlformats.org/drawingml/2006/main">
             <a:pPr algn="ctr">
+              <a:buNone/>
               <a:defRPr sz="825" b="1">
                 <a:solidFill>
                   <a:srgbClr val="F7F8F5"/>
@@ -14604,6 +14740,7 @@
           <a:lstStyle xmlns:a="http://schemas.openxmlformats.org/drawingml/2006/main"/>
           <a:p xmlns:a="http://schemas.openxmlformats.org/drawingml/2006/main">
             <a:pPr algn="ctr">
+              <a:buNone/>
               <a:defRPr sz="825" b="1">
                 <a:solidFill>
                   <a:srgbClr val="F7F8F5"/>
@@ -14695,6 +14832,7 @@
           <a:lstStyle xmlns:a="http://schemas.openxmlformats.org/drawingml/2006/main"/>
           <a:p xmlns:a="http://schemas.openxmlformats.org/drawingml/2006/main">
             <a:pPr algn="ctr">
+              <a:buNone/>
               <a:defRPr sz="825" b="1">
                 <a:solidFill>
                   <a:srgbClr val="F7F8F5"/>
@@ -14786,6 +14924,7 @@
           <a:lstStyle xmlns:a="http://schemas.openxmlformats.org/drawingml/2006/main"/>
           <a:p xmlns:a="http://schemas.openxmlformats.org/drawingml/2006/main">
             <a:pPr algn="ctr">
+              <a:buNone/>
               <a:defRPr sz="975" b="1">
                 <a:solidFill>
                   <a:srgbClr val="0B1720"/>
@@ -14842,6 +14981,7 @@
           <a:lstStyle xmlns:a="http://schemas.openxmlformats.org/drawingml/2006/main"/>
           <a:p xmlns:a="http://schemas.openxmlformats.org/drawingml/2006/main">
             <a:pPr algn="r">
+              <a:buNone/>
               <a:defRPr sz="825" b="1">
                 <a:solidFill>
                   <a:srgbClr val="5F7078"/>
@@ -15888,6 +16028,7 @@
           <a:lstStyle xmlns:a="http://schemas.openxmlformats.org/drawingml/2006/main"/>
           <a:p xmlns:a="http://schemas.openxmlformats.org/drawingml/2006/main">
             <a:pPr algn="l">
+              <a:buNone/>
               <a:defRPr sz="900" b="1">
                 <a:solidFill>
                   <a:srgbClr val="83F3C9"/>
@@ -15944,6 +16085,7 @@
           <a:lstStyle xmlns:a="http://schemas.openxmlformats.org/drawingml/2006/main"/>
           <a:p xmlns:a="http://schemas.openxmlformats.org/drawingml/2006/main">
             <a:pPr algn="l">
+              <a:buNone/>
               <a:defRPr sz="4125" b="1">
                 <a:solidFill>
                   <a:srgbClr val="F7F8F5"/>
@@ -15967,6 +16109,7 @@
           </a:p>
           <a:p xmlns:a="http://schemas.openxmlformats.org/drawingml/2006/main">
             <a:pPr algn="l">
+              <a:buNone/>
               <a:defRPr sz="4125" b="1">
                 <a:solidFill>
                   <a:srgbClr val="F7F8F5"/>
@@ -16023,6 +16166,7 @@
           <a:lstStyle xmlns:a="http://schemas.openxmlformats.org/drawingml/2006/main"/>
           <a:p xmlns:a="http://schemas.openxmlformats.org/drawingml/2006/main">
             <a:pPr algn="l">
+              <a:buNone/>
               <a:defRPr sz="1725" b="0">
                 <a:solidFill>
                   <a:srgbClr val="9AA8AE"/>
@@ -16046,6 +16190,7 @@
           </a:p>
           <a:p xmlns:a="http://schemas.openxmlformats.org/drawingml/2006/main">
             <a:pPr algn="l">
+              <a:buNone/>
               <a:defRPr sz="1725" b="0">
                 <a:solidFill>
                   <a:srgbClr val="9AA8AE"/>
@@ -16133,6 +16278,7 @@
           <a:lstStyle xmlns:a="http://schemas.openxmlformats.org/drawingml/2006/main"/>
           <a:p xmlns:a="http://schemas.openxmlformats.org/drawingml/2006/main">
             <a:pPr algn="l">
+              <a:buNone/>
               <a:defRPr sz="825" b="1">
                 <a:solidFill>
                   <a:srgbClr val="83F3C9"/>
@@ -16189,6 +16335,7 @@
           <a:lstStyle xmlns:a="http://schemas.openxmlformats.org/drawingml/2006/main"/>
           <a:p xmlns:a="http://schemas.openxmlformats.org/drawingml/2006/main">
             <a:pPr algn="l">
+              <a:buNone/>
               <a:defRPr sz="1950" b="1">
                 <a:solidFill>
                   <a:srgbClr val="F7F8F5"/>
@@ -16245,6 +16392,7 @@
           <a:lstStyle xmlns:a="http://schemas.openxmlformats.org/drawingml/2006/main"/>
           <a:p xmlns:a="http://schemas.openxmlformats.org/drawingml/2006/main">
             <a:pPr algn="ctr">
+              <a:buNone/>
               <a:defRPr sz="1800" b="0">
                 <a:solidFill>
                   <a:srgbClr val="9AA8AE"/>
@@ -16301,6 +16449,7 @@
           <a:lstStyle xmlns:a="http://schemas.openxmlformats.org/drawingml/2006/main"/>
           <a:p xmlns:a="http://schemas.openxmlformats.org/drawingml/2006/main">
             <a:pPr algn="l">
+              <a:buNone/>
               <a:defRPr sz="825" b="1">
                 <a:solidFill>
                   <a:srgbClr val="83F3C9"/>
@@ -16357,6 +16506,7 @@
           <a:lstStyle xmlns:a="http://schemas.openxmlformats.org/drawingml/2006/main"/>
           <a:p xmlns:a="http://schemas.openxmlformats.org/drawingml/2006/main">
             <a:pPr algn="l">
+              <a:buNone/>
               <a:defRPr sz="1950" b="1">
                 <a:solidFill>
                   <a:srgbClr val="F7F8F5"/>
@@ -16413,6 +16563,7 @@
           <a:lstStyle xmlns:a="http://schemas.openxmlformats.org/drawingml/2006/main"/>
           <a:p xmlns:a="http://schemas.openxmlformats.org/drawingml/2006/main">
             <a:pPr algn="ctr">
+              <a:buNone/>
               <a:defRPr sz="1800" b="0">
                 <a:solidFill>
                   <a:srgbClr val="9AA8AE"/>
@@ -16469,6 +16620,7 @@
           <a:lstStyle xmlns:a="http://schemas.openxmlformats.org/drawingml/2006/main"/>
           <a:p xmlns:a="http://schemas.openxmlformats.org/drawingml/2006/main">
             <a:pPr algn="l">
+              <a:buNone/>
               <a:defRPr sz="825" b="1">
                 <a:solidFill>
                   <a:srgbClr val="83F3C9"/>
@@ -16525,6 +16677,7 @@
           <a:lstStyle xmlns:a="http://schemas.openxmlformats.org/drawingml/2006/main"/>
           <a:p xmlns:a="http://schemas.openxmlformats.org/drawingml/2006/main">
             <a:pPr algn="l">
+              <a:buNone/>
               <a:defRPr sz="1950" b="1">
                 <a:solidFill>
                   <a:srgbClr val="F7F8F5"/>
@@ -16616,6 +16769,7 @@
           <a:lstStyle xmlns:a="http://schemas.openxmlformats.org/drawingml/2006/main"/>
           <a:p xmlns:a="http://schemas.openxmlformats.org/drawingml/2006/main">
             <a:pPr algn="ctr">
+              <a:buNone/>
               <a:defRPr sz="975" b="1">
                 <a:solidFill>
                   <a:srgbClr val="0B1720"/>
@@ -16672,6 +16826,7 @@
           <a:lstStyle xmlns:a="http://schemas.openxmlformats.org/drawingml/2006/main"/>
           <a:p xmlns:a="http://schemas.openxmlformats.org/drawingml/2006/main">
             <a:pPr algn="r">
+              <a:buNone/>
               <a:defRPr sz="825" b="1">
                 <a:solidFill>
                   <a:srgbClr val="5F7078"/>
@@ -16788,6 +16943,7 @@
           <a:lstStyle xmlns:a="http://schemas.openxmlformats.org/drawingml/2006/main"/>
           <a:p xmlns:a="http://schemas.openxmlformats.org/drawingml/2006/main">
             <a:pPr algn="l">
+              <a:buNone/>
               <a:defRPr sz="900" b="1">
                 <a:solidFill>
                   <a:srgbClr val="247B63"/>
@@ -16844,6 +17000,7 @@
           <a:lstStyle xmlns:a="http://schemas.openxmlformats.org/drawingml/2006/main"/>
           <a:p xmlns:a="http://schemas.openxmlformats.org/drawingml/2006/main">
             <a:pPr algn="l">
+              <a:buNone/>
               <a:defRPr sz="3450" b="1">
                 <a:solidFill>
                   <a:srgbClr val="0B1720"/>
@@ -16900,6 +17057,7 @@
           <a:lstStyle xmlns:a="http://schemas.openxmlformats.org/drawingml/2006/main"/>
           <a:p xmlns:a="http://schemas.openxmlformats.org/drawingml/2006/main">
             <a:pPr algn="l">
+              <a:buNone/>
               <a:defRPr sz="825" b="1">
                 <a:solidFill>
                   <a:srgbClr val="247B63"/>
@@ -16956,6 +17114,7 @@
           <a:lstStyle xmlns:a="http://schemas.openxmlformats.org/drawingml/2006/main"/>
           <a:p xmlns:a="http://schemas.openxmlformats.org/drawingml/2006/main">
             <a:pPr algn="l">
+              <a:buNone/>
               <a:defRPr sz="4950" b="1">
                 <a:solidFill>
                   <a:srgbClr val="0B1720"/>
@@ -17012,6 +17171,7 @@
           <a:lstStyle xmlns:a="http://schemas.openxmlformats.org/drawingml/2006/main"/>
           <a:p xmlns:a="http://schemas.openxmlformats.org/drawingml/2006/main">
             <a:pPr algn="l">
+              <a:buNone/>
               <a:defRPr sz="1500" b="0">
                 <a:solidFill>
                   <a:srgbClr val="5F7078"/>
@@ -17099,6 +17259,7 @@
           <a:lstStyle xmlns:a="http://schemas.openxmlformats.org/drawingml/2006/main"/>
           <a:p xmlns:a="http://schemas.openxmlformats.org/drawingml/2006/main">
             <a:pPr algn="l">
+              <a:buNone/>
               <a:defRPr sz="825" b="1">
                 <a:solidFill>
                   <a:srgbClr val="247B63"/>
@@ -17155,6 +17316,7 @@
           <a:lstStyle xmlns:a="http://schemas.openxmlformats.org/drawingml/2006/main"/>
           <a:p xmlns:a="http://schemas.openxmlformats.org/drawingml/2006/main">
             <a:pPr algn="l">
+              <a:buNone/>
               <a:defRPr sz="4950" b="1">
                 <a:solidFill>
                   <a:srgbClr val="0B1720"/>
@@ -17211,6 +17373,7 @@
           <a:lstStyle xmlns:a="http://schemas.openxmlformats.org/drawingml/2006/main"/>
           <a:p xmlns:a="http://schemas.openxmlformats.org/drawingml/2006/main">
             <a:pPr algn="l">
+              <a:buNone/>
               <a:defRPr sz="1500" b="0">
                 <a:solidFill>
                   <a:srgbClr val="5F7078"/>
@@ -17298,6 +17461,7 @@
           <a:lstStyle xmlns:a="http://schemas.openxmlformats.org/drawingml/2006/main"/>
           <a:p xmlns:a="http://schemas.openxmlformats.org/drawingml/2006/main">
             <a:pPr algn="l">
+              <a:buNone/>
               <a:defRPr sz="825" b="1">
                 <a:solidFill>
                   <a:srgbClr val="247B63"/>
@@ -17354,6 +17518,7 @@
           <a:lstStyle xmlns:a="http://schemas.openxmlformats.org/drawingml/2006/main"/>
           <a:p xmlns:a="http://schemas.openxmlformats.org/drawingml/2006/main">
             <a:pPr algn="l">
+              <a:buNone/>
               <a:defRPr sz="4950" b="1">
                 <a:solidFill>
                   <a:srgbClr val="0B1720"/>
@@ -17410,6 +17575,7 @@
           <a:lstStyle xmlns:a="http://schemas.openxmlformats.org/drawingml/2006/main"/>
           <a:p xmlns:a="http://schemas.openxmlformats.org/drawingml/2006/main">
             <a:pPr algn="l">
+              <a:buNone/>
               <a:defRPr sz="1500" b="0">
                 <a:solidFill>
                   <a:srgbClr val="5F7078"/>
@@ -17501,6 +17667,7 @@
           <a:lstStyle xmlns:a="http://schemas.openxmlformats.org/drawingml/2006/main"/>
           <a:p xmlns:a="http://schemas.openxmlformats.org/drawingml/2006/main">
             <a:pPr algn="ctr">
+              <a:buNone/>
               <a:defRPr sz="1725" b="1">
                 <a:solidFill>
                   <a:srgbClr val="F7F8F5"/>
@@ -17557,6 +17724,7 @@
           <a:lstStyle xmlns:a="http://schemas.openxmlformats.org/drawingml/2006/main"/>
           <a:p xmlns:a="http://schemas.openxmlformats.org/drawingml/2006/main">
             <a:pPr algn="l">
+              <a:buNone/>
               <a:defRPr sz="675" b="0">
                 <a:solidFill>
                   <a:srgbClr val="5F7078"/>
@@ -17613,6 +17781,7 @@
           <a:lstStyle xmlns:a="http://schemas.openxmlformats.org/drawingml/2006/main"/>
           <a:p xmlns:a="http://schemas.openxmlformats.org/drawingml/2006/main">
             <a:pPr algn="r">
+              <a:buNone/>
               <a:defRPr sz="825" b="1">
                 <a:solidFill>
                   <a:srgbClr val="5F7078"/>
@@ -18659,6 +18828,7 @@
           <a:lstStyle xmlns:a="http://schemas.openxmlformats.org/drawingml/2006/main"/>
           <a:p xmlns:a="http://schemas.openxmlformats.org/drawingml/2006/main">
             <a:pPr algn="l">
+              <a:buNone/>
               <a:defRPr sz="900" b="1">
                 <a:solidFill>
                   <a:srgbClr val="83F3C9"/>
@@ -18715,6 +18885,7 @@
           <a:lstStyle xmlns:a="http://schemas.openxmlformats.org/drawingml/2006/main"/>
           <a:p xmlns:a="http://schemas.openxmlformats.org/drawingml/2006/main">
             <a:pPr algn="l">
+              <a:buNone/>
               <a:defRPr sz="3300" b="1">
                 <a:solidFill>
                   <a:srgbClr val="F7F8F5"/>
@@ -18771,6 +18942,7 @@
           <a:lstStyle xmlns:a="http://schemas.openxmlformats.org/drawingml/2006/main"/>
           <a:p xmlns:a="http://schemas.openxmlformats.org/drawingml/2006/main">
             <a:pPr algn="l">
+              <a:buNone/>
               <a:defRPr sz="1575" b="0">
                 <a:solidFill>
                   <a:srgbClr val="9AA8AE"/>
@@ -18862,6 +19034,7 @@
           <a:lstStyle xmlns:a="http://schemas.openxmlformats.org/drawingml/2006/main"/>
           <a:p xmlns:a="http://schemas.openxmlformats.org/drawingml/2006/main">
             <a:pPr algn="l">
+              <a:buNone/>
               <a:defRPr sz="900" b="1">
                 <a:solidFill>
                   <a:srgbClr val="83F3C9"/>
@@ -18918,6 +19091,7 @@
           <a:lstStyle xmlns:a="http://schemas.openxmlformats.org/drawingml/2006/main"/>
           <a:p xmlns:a="http://schemas.openxmlformats.org/drawingml/2006/main">
             <a:pPr algn="l">
+              <a:buNone/>
               <a:defRPr sz="1125" b="1">
                 <a:solidFill>
                   <a:srgbClr val="F7F8F5"/>
@@ -18974,6 +19148,7 @@
           <a:lstStyle xmlns:a="http://schemas.openxmlformats.org/drawingml/2006/main"/>
           <a:p xmlns:a="http://schemas.openxmlformats.org/drawingml/2006/main">
             <a:pPr algn="l">
+              <a:buNone/>
               <a:defRPr sz="825" b="0">
                 <a:solidFill>
                   <a:srgbClr val="9AA8AE"/>
@@ -19129,6 +19304,7 @@
           <a:lstStyle xmlns:a="http://schemas.openxmlformats.org/drawingml/2006/main"/>
           <a:p xmlns:a="http://schemas.openxmlformats.org/drawingml/2006/main">
             <a:pPr algn="l">
+              <a:buNone/>
               <a:defRPr sz="900" b="1">
                 <a:solidFill>
                   <a:srgbClr val="83F3C9"/>
@@ -19185,6 +19361,7 @@
           <a:lstStyle xmlns:a="http://schemas.openxmlformats.org/drawingml/2006/main"/>
           <a:p xmlns:a="http://schemas.openxmlformats.org/drawingml/2006/main">
             <a:pPr algn="l">
+              <a:buNone/>
               <a:defRPr sz="1125" b="1">
                 <a:solidFill>
                   <a:srgbClr val="F7F8F5"/>
@@ -19241,6 +19418,7 @@
           <a:lstStyle xmlns:a="http://schemas.openxmlformats.org/drawingml/2006/main"/>
           <a:p xmlns:a="http://schemas.openxmlformats.org/drawingml/2006/main">
             <a:pPr algn="l">
+              <a:buNone/>
               <a:defRPr sz="825" b="0">
                 <a:solidFill>
                   <a:srgbClr val="9AA8AE"/>
@@ -19396,6 +19574,7 @@
           <a:lstStyle xmlns:a="http://schemas.openxmlformats.org/drawingml/2006/main"/>
           <a:p xmlns:a="http://schemas.openxmlformats.org/drawingml/2006/main">
             <a:pPr algn="l">
+              <a:buNone/>
               <a:defRPr sz="900" b="1">
                 <a:solidFill>
                   <a:srgbClr val="83F3C9"/>
@@ -19452,6 +19631,7 @@
           <a:lstStyle xmlns:a="http://schemas.openxmlformats.org/drawingml/2006/main"/>
           <a:p xmlns:a="http://schemas.openxmlformats.org/drawingml/2006/main">
             <a:pPr algn="l">
+              <a:buNone/>
               <a:defRPr sz="1125" b="1">
                 <a:solidFill>
                   <a:srgbClr val="F7F8F5"/>
@@ -19475,6 +19655,7 @@
           </a:p>
           <a:p xmlns:a="http://schemas.openxmlformats.org/drawingml/2006/main">
             <a:pPr algn="l">
+              <a:buNone/>
               <a:defRPr sz="1125" b="1">
                 <a:solidFill>
                   <a:srgbClr val="F7F8F5"/>
@@ -19531,6 +19712,7 @@
           <a:lstStyle xmlns:a="http://schemas.openxmlformats.org/drawingml/2006/main"/>
           <a:p xmlns:a="http://schemas.openxmlformats.org/drawingml/2006/main">
             <a:pPr algn="l">
+              <a:buNone/>
               <a:defRPr sz="825" b="0">
                 <a:solidFill>
                   <a:srgbClr val="9AA8AE"/>
@@ -19686,6 +19868,7 @@
           <a:lstStyle xmlns:a="http://schemas.openxmlformats.org/drawingml/2006/main"/>
           <a:p xmlns:a="http://schemas.openxmlformats.org/drawingml/2006/main">
             <a:pPr algn="l">
+              <a:buNone/>
               <a:defRPr sz="900" b="1">
                 <a:solidFill>
                   <a:srgbClr val="83F3C9"/>
@@ -19742,6 +19925,7 @@
           <a:lstStyle xmlns:a="http://schemas.openxmlformats.org/drawingml/2006/main"/>
           <a:p xmlns:a="http://schemas.openxmlformats.org/drawingml/2006/main">
             <a:pPr algn="l">
+              <a:buNone/>
               <a:defRPr sz="1125" b="1">
                 <a:solidFill>
                   <a:srgbClr val="F7F8F5"/>
@@ -19798,6 +19982,7 @@
           <a:lstStyle xmlns:a="http://schemas.openxmlformats.org/drawingml/2006/main"/>
           <a:p xmlns:a="http://schemas.openxmlformats.org/drawingml/2006/main">
             <a:pPr algn="l">
+              <a:buNone/>
               <a:defRPr sz="825" b="0">
                 <a:solidFill>
                   <a:srgbClr val="9AA8AE"/>
@@ -19953,6 +20138,7 @@
           <a:lstStyle xmlns:a="http://schemas.openxmlformats.org/drawingml/2006/main"/>
           <a:p xmlns:a="http://schemas.openxmlformats.org/drawingml/2006/main">
             <a:pPr algn="l">
+              <a:buNone/>
               <a:defRPr sz="900" b="1">
                 <a:solidFill>
                   <a:srgbClr val="0B1720"/>
@@ -20009,6 +20195,7 @@
           <a:lstStyle xmlns:a="http://schemas.openxmlformats.org/drawingml/2006/main"/>
           <a:p xmlns:a="http://schemas.openxmlformats.org/drawingml/2006/main">
             <a:pPr algn="l">
+              <a:buNone/>
               <a:defRPr sz="1125" b="1">
                 <a:solidFill>
                   <a:srgbClr val="0B1720"/>
@@ -20065,6 +20252,7 @@
           <a:lstStyle xmlns:a="http://schemas.openxmlformats.org/drawingml/2006/main"/>
           <a:p xmlns:a="http://schemas.openxmlformats.org/drawingml/2006/main">
             <a:pPr algn="l">
+              <a:buNone/>
               <a:defRPr sz="825" b="0">
                 <a:solidFill>
                   <a:srgbClr val="247B63"/>
@@ -20121,6 +20309,7 @@
           <a:lstStyle xmlns:a="http://schemas.openxmlformats.org/drawingml/2006/main"/>
           <a:p xmlns:a="http://schemas.openxmlformats.org/drawingml/2006/main">
             <a:pPr algn="l">
+              <a:buNone/>
               <a:defRPr sz="1650" b="0">
                 <a:solidFill>
                   <a:srgbClr val="F7F8F5"/>
@@ -20177,6 +20366,7 @@
           <a:lstStyle xmlns:a="http://schemas.openxmlformats.org/drawingml/2006/main"/>
           <a:p xmlns:a="http://schemas.openxmlformats.org/drawingml/2006/main">
             <a:pPr algn="l">
+              <a:buNone/>
               <a:defRPr sz="2550" b="1">
                 <a:solidFill>
                   <a:srgbClr val="83F3C9"/>
@@ -20233,6 +20423,7 @@
           <a:lstStyle xmlns:a="http://schemas.openxmlformats.org/drawingml/2006/main"/>
           <a:p xmlns:a="http://schemas.openxmlformats.org/drawingml/2006/main">
             <a:pPr algn="r">
+              <a:buNone/>
               <a:defRPr sz="825" b="1">
                 <a:solidFill>
                   <a:srgbClr val="5F7078"/>
@@ -20349,6 +20540,7 @@
           <a:lstStyle xmlns:a="http://schemas.openxmlformats.org/drawingml/2006/main"/>
           <a:p xmlns:a="http://schemas.openxmlformats.org/drawingml/2006/main">
             <a:pPr algn="l">
+              <a:buNone/>
               <a:defRPr sz="900" b="1">
                 <a:solidFill>
                   <a:srgbClr val="247B63"/>
@@ -20405,6 +20597,7 @@
           <a:lstStyle xmlns:a="http://schemas.openxmlformats.org/drawingml/2006/main"/>
           <a:p xmlns:a="http://schemas.openxmlformats.org/drawingml/2006/main">
             <a:pPr algn="l">
+              <a:buNone/>
               <a:defRPr sz="3300" b="1">
                 <a:solidFill>
                   <a:srgbClr val="0B1720"/>
@@ -20461,6 +20654,7 @@
           <a:lstStyle xmlns:a="http://schemas.openxmlformats.org/drawingml/2006/main"/>
           <a:p xmlns:a="http://schemas.openxmlformats.org/drawingml/2006/main">
             <a:pPr algn="l">
+              <a:buNone/>
               <a:defRPr sz="1575" b="0">
                 <a:solidFill>
                   <a:srgbClr val="5F7078"/>
@@ -20552,6 +20746,7 @@
           <a:lstStyle xmlns:a="http://schemas.openxmlformats.org/drawingml/2006/main"/>
           <a:p xmlns:a="http://schemas.openxmlformats.org/drawingml/2006/main">
             <a:pPr algn="l">
+              <a:buNone/>
               <a:defRPr sz="900" b="1">
                 <a:solidFill>
                   <a:srgbClr val="247B63"/>
@@ -20608,6 +20803,7 @@
           <a:lstStyle xmlns:a="http://schemas.openxmlformats.org/drawingml/2006/main"/>
           <a:p xmlns:a="http://schemas.openxmlformats.org/drawingml/2006/main">
             <a:pPr algn="l">
+              <a:buNone/>
               <a:defRPr sz="1650" b="1">
                 <a:solidFill>
                   <a:srgbClr val="5F7078"/>
@@ -20664,6 +20860,7 @@
           <a:lstStyle xmlns:a="http://schemas.openxmlformats.org/drawingml/2006/main"/>
           <a:p xmlns:a="http://schemas.openxmlformats.org/drawingml/2006/main">
             <a:pPr algn="l">
+              <a:buNone/>
               <a:defRPr sz="1350" b="0">
                 <a:solidFill>
                   <a:srgbClr val="5F7078"/>
@@ -20720,6 +20917,7 @@
           <a:lstStyle xmlns:a="http://schemas.openxmlformats.org/drawingml/2006/main"/>
           <a:p xmlns:a="http://schemas.openxmlformats.org/drawingml/2006/main">
             <a:pPr algn="ctr">
+              <a:buNone/>
               <a:defRPr sz="1800" b="1">
                 <a:solidFill>
                   <a:srgbClr val="5F7078"/>
@@ -20811,6 +21009,7 @@
           <a:lstStyle xmlns:a="http://schemas.openxmlformats.org/drawingml/2006/main"/>
           <a:p xmlns:a="http://schemas.openxmlformats.org/drawingml/2006/main">
             <a:pPr algn="l">
+              <a:buNone/>
               <a:defRPr sz="900" b="1">
                 <a:solidFill>
                   <a:srgbClr val="247B63"/>
@@ -20867,6 +21066,7 @@
           <a:lstStyle xmlns:a="http://schemas.openxmlformats.org/drawingml/2006/main"/>
           <a:p xmlns:a="http://schemas.openxmlformats.org/drawingml/2006/main">
             <a:pPr algn="l">
+              <a:buNone/>
               <a:defRPr sz="1650" b="1">
                 <a:solidFill>
                   <a:srgbClr val="5F7078"/>
@@ -20923,6 +21123,7 @@
           <a:lstStyle xmlns:a="http://schemas.openxmlformats.org/drawingml/2006/main"/>
           <a:p xmlns:a="http://schemas.openxmlformats.org/drawingml/2006/main">
             <a:pPr algn="l">
+              <a:buNone/>
               <a:defRPr sz="1350" b="0">
                 <a:solidFill>
                   <a:srgbClr val="5F7078"/>
@@ -20979,6 +21180,7 @@
           <a:lstStyle xmlns:a="http://schemas.openxmlformats.org/drawingml/2006/main"/>
           <a:p xmlns:a="http://schemas.openxmlformats.org/drawingml/2006/main">
             <a:pPr algn="ctr">
+              <a:buNone/>
               <a:defRPr sz="1800" b="1">
                 <a:solidFill>
                   <a:srgbClr val="5F7078"/>
@@ -21070,6 +21272,7 @@
           <a:lstStyle xmlns:a="http://schemas.openxmlformats.org/drawingml/2006/main"/>
           <a:p xmlns:a="http://schemas.openxmlformats.org/drawingml/2006/main">
             <a:pPr algn="l">
+              <a:buNone/>
               <a:defRPr sz="900" b="1">
                 <a:solidFill>
                   <a:srgbClr val="247B63"/>
@@ -21126,6 +21329,7 @@
           <a:lstStyle xmlns:a="http://schemas.openxmlformats.org/drawingml/2006/main"/>
           <a:p xmlns:a="http://schemas.openxmlformats.org/drawingml/2006/main">
             <a:pPr algn="l">
+              <a:buNone/>
               <a:defRPr sz="1650" b="1">
                 <a:solidFill>
                   <a:srgbClr val="0B1720"/>
@@ -21182,6 +21386,7 @@
           <a:lstStyle xmlns:a="http://schemas.openxmlformats.org/drawingml/2006/main"/>
           <a:p xmlns:a="http://schemas.openxmlformats.org/drawingml/2006/main">
             <a:pPr algn="l">
+              <a:buNone/>
               <a:defRPr sz="1350" b="0">
                 <a:solidFill>
                   <a:srgbClr val="5F7078"/>
@@ -21238,6 +21443,7 @@
           <a:lstStyle xmlns:a="http://schemas.openxmlformats.org/drawingml/2006/main"/>
           <a:p xmlns:a="http://schemas.openxmlformats.org/drawingml/2006/main">
             <a:pPr algn="ctr">
+              <a:buNone/>
               <a:defRPr sz="1800" b="1">
                 <a:solidFill>
                   <a:srgbClr val="5F7078"/>
@@ -21329,6 +21535,7 @@
           <a:lstStyle xmlns:a="http://schemas.openxmlformats.org/drawingml/2006/main"/>
           <a:p xmlns:a="http://schemas.openxmlformats.org/drawingml/2006/main">
             <a:pPr algn="l">
+              <a:buNone/>
               <a:defRPr sz="900" b="1">
                 <a:solidFill>
                   <a:srgbClr val="83F3C9"/>
@@ -21385,6 +21592,7 @@
           <a:lstStyle xmlns:a="http://schemas.openxmlformats.org/drawingml/2006/main"/>
           <a:p xmlns:a="http://schemas.openxmlformats.org/drawingml/2006/main">
             <a:pPr algn="l">
+              <a:buNone/>
               <a:defRPr sz="1650" b="1">
                 <a:solidFill>
                   <a:srgbClr val="F7F8F5"/>
@@ -21441,6 +21649,7 @@
           <a:lstStyle xmlns:a="http://schemas.openxmlformats.org/drawingml/2006/main"/>
           <a:p xmlns:a="http://schemas.openxmlformats.org/drawingml/2006/main">
             <a:pPr algn="l">
+              <a:buNone/>
               <a:defRPr sz="1350" b="0">
                 <a:solidFill>
                   <a:srgbClr val="C4D2D5"/>
@@ -21497,6 +21706,7 @@
           <a:lstStyle xmlns:a="http://schemas.openxmlformats.org/drawingml/2006/main"/>
           <a:p xmlns:a="http://schemas.openxmlformats.org/drawingml/2006/main">
             <a:pPr algn="ctr">
+              <a:buNone/>
               <a:defRPr sz="900" b="1">
                 <a:solidFill>
                   <a:srgbClr val="5F7078"/>
@@ -21553,6 +21763,7 @@
           <a:lstStyle xmlns:a="http://schemas.openxmlformats.org/drawingml/2006/main"/>
           <a:p xmlns:a="http://schemas.openxmlformats.org/drawingml/2006/main">
             <a:pPr algn="ctr">
+              <a:buNone/>
               <a:defRPr sz="900" b="1">
                 <a:solidFill>
                   <a:srgbClr val="5F7078"/>
@@ -21609,6 +21820,7 @@
           <a:lstStyle xmlns:a="http://schemas.openxmlformats.org/drawingml/2006/main"/>
           <a:p xmlns:a="http://schemas.openxmlformats.org/drawingml/2006/main">
             <a:pPr algn="ctr">
+              <a:buNone/>
               <a:defRPr sz="900" b="1">
                 <a:solidFill>
                   <a:srgbClr val="5F7078"/>
@@ -21665,6 +21877,7 @@
           <a:lstStyle xmlns:a="http://schemas.openxmlformats.org/drawingml/2006/main"/>
           <a:p xmlns:a="http://schemas.openxmlformats.org/drawingml/2006/main">
             <a:pPr algn="ctr">
+              <a:buNone/>
               <a:defRPr sz="900" b="1">
                 <a:solidFill>
                   <a:srgbClr val="247B63"/>
@@ -21752,6 +21965,7 @@
           <a:lstStyle xmlns:a="http://schemas.openxmlformats.org/drawingml/2006/main"/>
           <a:p xmlns:a="http://schemas.openxmlformats.org/drawingml/2006/main">
             <a:pPr algn="r">
+              <a:buNone/>
               <a:defRPr sz="825" b="1">
                 <a:solidFill>
                   <a:srgbClr val="5F7078"/>
@@ -22798,6 +23012,7 @@
           <a:lstStyle xmlns:a="http://schemas.openxmlformats.org/drawingml/2006/main"/>
           <a:p xmlns:a="http://schemas.openxmlformats.org/drawingml/2006/main">
             <a:pPr algn="l">
+              <a:buNone/>
               <a:defRPr sz="900" b="1">
                 <a:solidFill>
                   <a:srgbClr val="83F3C9"/>
@@ -22854,6 +23069,7 @@
           <a:lstStyle xmlns:a="http://schemas.openxmlformats.org/drawingml/2006/main"/>
           <a:p xmlns:a="http://schemas.openxmlformats.org/drawingml/2006/main">
             <a:pPr algn="l">
+              <a:buNone/>
               <a:defRPr sz="3300" b="1">
                 <a:solidFill>
                   <a:srgbClr val="F7F8F5"/>
@@ -22910,6 +23126,7 @@
           <a:lstStyle xmlns:a="http://schemas.openxmlformats.org/drawingml/2006/main"/>
           <a:p xmlns:a="http://schemas.openxmlformats.org/drawingml/2006/main">
             <a:pPr algn="l">
+              <a:buNone/>
               <a:defRPr sz="1425" b="0">
                 <a:solidFill>
                   <a:srgbClr val="83F3C9"/>
@@ -23001,6 +23218,7 @@
           <a:lstStyle xmlns:a="http://schemas.openxmlformats.org/drawingml/2006/main"/>
           <a:p xmlns:a="http://schemas.openxmlformats.org/drawingml/2006/main">
             <a:pPr algn="ctr">
+              <a:buNone/>
               <a:defRPr sz="975" b="1">
                 <a:solidFill>
                   <a:srgbClr val="7AA7FF"/>
@@ -23057,6 +23275,7 @@
           <a:lstStyle xmlns:a="http://schemas.openxmlformats.org/drawingml/2006/main"/>
           <a:p xmlns:a="http://schemas.openxmlformats.org/drawingml/2006/main">
             <a:pPr algn="l">
+              <a:buNone/>
               <a:defRPr sz="1350" b="1">
                 <a:solidFill>
                   <a:srgbClr val="F7F8F5"/>
@@ -23080,6 +23299,7 @@
           </a:p>
           <a:p xmlns:a="http://schemas.openxmlformats.org/drawingml/2006/main">
             <a:pPr algn="l">
+              <a:buNone/>
               <a:defRPr sz="1350" b="1">
                 <a:solidFill>
                   <a:srgbClr val="F7F8F5"/>
@@ -23202,6 +23422,7 @@
           <a:lstStyle xmlns:a="http://schemas.openxmlformats.org/drawingml/2006/main"/>
           <a:p xmlns:a="http://schemas.openxmlformats.org/drawingml/2006/main">
             <a:pPr algn="ctr">
+              <a:buNone/>
               <a:defRPr sz="975" b="1">
                 <a:solidFill>
                   <a:srgbClr val="51DFE3"/>
@@ -23258,6 +23479,7 @@
           <a:lstStyle xmlns:a="http://schemas.openxmlformats.org/drawingml/2006/main"/>
           <a:p xmlns:a="http://schemas.openxmlformats.org/drawingml/2006/main">
             <a:pPr algn="l">
+              <a:buNone/>
               <a:defRPr sz="1350" b="1">
                 <a:solidFill>
                   <a:srgbClr val="F7F8F5"/>
@@ -23281,6 +23503,7 @@
           </a:p>
           <a:p xmlns:a="http://schemas.openxmlformats.org/drawingml/2006/main">
             <a:pPr algn="l">
+              <a:buNone/>
               <a:defRPr sz="1350" b="1">
                 <a:solidFill>
                   <a:srgbClr val="F7F8F5"/>
@@ -23403,6 +23626,7 @@
           <a:lstStyle xmlns:a="http://schemas.openxmlformats.org/drawingml/2006/main"/>
           <a:p xmlns:a="http://schemas.openxmlformats.org/drawingml/2006/main">
             <a:pPr algn="ctr">
+              <a:buNone/>
               <a:defRPr sz="975" b="1">
                 <a:solidFill>
                   <a:srgbClr val="F3C668"/>
@@ -23459,6 +23683,7 @@
           <a:lstStyle xmlns:a="http://schemas.openxmlformats.org/drawingml/2006/main"/>
           <a:p xmlns:a="http://schemas.openxmlformats.org/drawingml/2006/main">
             <a:pPr algn="l">
+              <a:buNone/>
               <a:defRPr sz="1350" b="1">
                 <a:solidFill>
                   <a:srgbClr val="F7F8F5"/>
@@ -23581,6 +23806,7 @@
           <a:lstStyle xmlns:a="http://schemas.openxmlformats.org/drawingml/2006/main"/>
           <a:p xmlns:a="http://schemas.openxmlformats.org/drawingml/2006/main">
             <a:pPr algn="ctr">
+              <a:buNone/>
               <a:defRPr sz="975" b="1">
                 <a:solidFill>
                   <a:srgbClr val="60D799"/>
@@ -23637,6 +23863,7 @@
           <a:lstStyle xmlns:a="http://schemas.openxmlformats.org/drawingml/2006/main"/>
           <a:p xmlns:a="http://schemas.openxmlformats.org/drawingml/2006/main">
             <a:pPr algn="l">
+              <a:buNone/>
               <a:defRPr sz="1350" b="1">
                 <a:solidFill>
                   <a:srgbClr val="F7F8F5"/>
@@ -23660,6 +23887,7 @@
           </a:p>
           <a:p xmlns:a="http://schemas.openxmlformats.org/drawingml/2006/main">
             <a:pPr algn="l">
+              <a:buNone/>
               <a:defRPr sz="1350" b="1">
                 <a:solidFill>
                   <a:srgbClr val="F7F8F5"/>
@@ -23782,6 +24010,7 @@
           <a:lstStyle xmlns:a="http://schemas.openxmlformats.org/drawingml/2006/main"/>
           <a:p xmlns:a="http://schemas.openxmlformats.org/drawingml/2006/main">
             <a:pPr algn="ctr">
+              <a:buNone/>
               <a:defRPr sz="975" b="1">
                 <a:solidFill>
                   <a:srgbClr val="AA91FF"/>
@@ -23838,6 +24067,7 @@
           <a:lstStyle xmlns:a="http://schemas.openxmlformats.org/drawingml/2006/main"/>
           <a:p xmlns:a="http://schemas.openxmlformats.org/drawingml/2006/main">
             <a:pPr algn="l">
+              <a:buNone/>
               <a:defRPr sz="1350" b="1">
                 <a:solidFill>
                   <a:srgbClr val="F7F8F5"/>
@@ -23861,6 +24091,7 @@
           </a:p>
           <a:p xmlns:a="http://schemas.openxmlformats.org/drawingml/2006/main">
             <a:pPr algn="l">
+              <a:buNone/>
               <a:defRPr sz="1350" b="1">
                 <a:solidFill>
                   <a:srgbClr val="F7F8F5"/>
@@ -23983,6 +24214,7 @@
           <a:lstStyle xmlns:a="http://schemas.openxmlformats.org/drawingml/2006/main"/>
           <a:p xmlns:a="http://schemas.openxmlformats.org/drawingml/2006/main">
             <a:pPr algn="ctr">
+              <a:buNone/>
               <a:defRPr sz="975" b="1">
                 <a:solidFill>
                   <a:srgbClr val="FF7487"/>
@@ -24039,6 +24271,7 @@
           <a:lstStyle xmlns:a="http://schemas.openxmlformats.org/drawingml/2006/main"/>
           <a:p xmlns:a="http://schemas.openxmlformats.org/drawingml/2006/main">
             <a:pPr algn="l">
+              <a:buNone/>
               <a:defRPr sz="1350" b="1">
                 <a:solidFill>
                   <a:srgbClr val="F7F8F5"/>
@@ -24062,6 +24295,7 @@
           </a:p>
           <a:p xmlns:a="http://schemas.openxmlformats.org/drawingml/2006/main">
             <a:pPr algn="l">
+              <a:buNone/>
               <a:defRPr sz="1350" b="1">
                 <a:solidFill>
                   <a:srgbClr val="F7F8F5"/>
@@ -24184,6 +24418,7 @@
           <a:lstStyle xmlns:a="http://schemas.openxmlformats.org/drawingml/2006/main"/>
           <a:p xmlns:a="http://schemas.openxmlformats.org/drawingml/2006/main">
             <a:pPr algn="l">
+              <a:buNone/>
               <a:defRPr sz="825" b="1">
                 <a:solidFill>
                   <a:srgbClr val="83F3C9"/>
@@ -24240,6 +24475,7 @@
           <a:lstStyle xmlns:a="http://schemas.openxmlformats.org/drawingml/2006/main"/>
           <a:p xmlns:a="http://schemas.openxmlformats.org/drawingml/2006/main">
             <a:pPr algn="l">
+              <a:buNone/>
               <a:defRPr sz="1200" b="0">
                 <a:solidFill>
                   <a:srgbClr val="C3D0D3"/>
@@ -24331,6 +24567,7 @@
           <a:lstStyle xmlns:a="http://schemas.openxmlformats.org/drawingml/2006/main"/>
           <a:p xmlns:a="http://schemas.openxmlformats.org/drawingml/2006/main">
             <a:pPr algn="l">
+              <a:buNone/>
               <a:defRPr sz="825" b="1">
                 <a:solidFill>
                   <a:srgbClr val="83F3C9"/>
@@ -24387,6 +24624,7 @@
           <a:lstStyle xmlns:a="http://schemas.openxmlformats.org/drawingml/2006/main"/>
           <a:p xmlns:a="http://schemas.openxmlformats.org/drawingml/2006/main">
             <a:pPr algn="l">
+              <a:buNone/>
               <a:defRPr sz="1200" b="0">
                 <a:solidFill>
                   <a:srgbClr val="C3D0D3"/>
@@ -24478,6 +24716,7 @@
           <a:lstStyle xmlns:a="http://schemas.openxmlformats.org/drawingml/2006/main"/>
           <a:p xmlns:a="http://schemas.openxmlformats.org/drawingml/2006/main">
             <a:pPr algn="l">
+              <a:buNone/>
               <a:defRPr sz="825" b="1">
                 <a:solidFill>
                   <a:srgbClr val="83F3C9"/>
@@ -24534,6 +24773,7 @@
           <a:lstStyle xmlns:a="http://schemas.openxmlformats.org/drawingml/2006/main"/>
           <a:p xmlns:a="http://schemas.openxmlformats.org/drawingml/2006/main">
             <a:pPr algn="l">
+              <a:buNone/>
               <a:defRPr sz="1200" b="0">
                 <a:solidFill>
                   <a:srgbClr val="C3D0D3"/>
@@ -24590,6 +24830,7 @@
           <a:lstStyle xmlns:a="http://schemas.openxmlformats.org/drawingml/2006/main"/>
           <a:p xmlns:a="http://schemas.openxmlformats.org/drawingml/2006/main">
             <a:pPr algn="l">
+              <a:buNone/>
               <a:defRPr sz="675" b="0">
                 <a:solidFill>
                   <a:srgbClr val="5F7078"/>
@@ -24646,6 +24887,7 @@
           <a:lstStyle xmlns:a="http://schemas.openxmlformats.org/drawingml/2006/main"/>
           <a:p xmlns:a="http://schemas.openxmlformats.org/drawingml/2006/main">
             <a:pPr algn="r">
+              <a:buNone/>
               <a:defRPr sz="825" b="1">
                 <a:solidFill>
                   <a:srgbClr val="5F7078"/>
@@ -24762,6 +25004,7 @@
           <a:lstStyle xmlns:a="http://schemas.openxmlformats.org/drawingml/2006/main"/>
           <a:p xmlns:a="http://schemas.openxmlformats.org/drawingml/2006/main">
             <a:pPr algn="l">
+              <a:buNone/>
               <a:defRPr sz="900" b="1">
                 <a:solidFill>
                   <a:srgbClr val="247B63"/>
@@ -24818,6 +25061,7 @@
           <a:lstStyle xmlns:a="http://schemas.openxmlformats.org/drawingml/2006/main"/>
           <a:p xmlns:a="http://schemas.openxmlformats.org/drawingml/2006/main">
             <a:pPr algn="l">
+              <a:buNone/>
               <a:defRPr sz="3300" b="1">
                 <a:solidFill>
                   <a:srgbClr val="0B1720"/>
@@ -24909,6 +25153,7 @@
           <a:lstStyle xmlns:a="http://schemas.openxmlformats.org/drawingml/2006/main"/>
           <a:p xmlns:a="http://schemas.openxmlformats.org/drawingml/2006/main">
             <a:pPr algn="ctr">
+              <a:buNone/>
               <a:defRPr sz="975" b="1">
                 <a:solidFill>
                   <a:srgbClr val="7AA7FF"/>
@@ -24965,6 +25210,7 @@
           <a:lstStyle xmlns:a="http://schemas.openxmlformats.org/drawingml/2006/main"/>
           <a:p xmlns:a="http://schemas.openxmlformats.org/drawingml/2006/main">
             <a:pPr algn="l">
+              <a:buNone/>
               <a:defRPr sz="1425" b="1">
                 <a:solidFill>
                   <a:srgbClr val="0B1720"/>
@@ -25021,6 +25267,7 @@
           <a:lstStyle xmlns:a="http://schemas.openxmlformats.org/drawingml/2006/main"/>
           <a:p xmlns:a="http://schemas.openxmlformats.org/drawingml/2006/main">
             <a:pPr algn="l">
+              <a:buNone/>
               <a:defRPr sz="1650" b="1">
                 <a:solidFill>
                   <a:srgbClr val="0B1720"/>
@@ -25174,6 +25421,7 @@
           <a:lstStyle xmlns:a="http://schemas.openxmlformats.org/drawingml/2006/main"/>
           <a:p xmlns:a="http://schemas.openxmlformats.org/drawingml/2006/main">
             <a:pPr algn="ctr">
+              <a:buNone/>
               <a:defRPr sz="975" b="1">
                 <a:solidFill>
                   <a:srgbClr val="51DFE3"/>
@@ -25230,6 +25478,7 @@
           <a:lstStyle xmlns:a="http://schemas.openxmlformats.org/drawingml/2006/main"/>
           <a:p xmlns:a="http://schemas.openxmlformats.org/drawingml/2006/main">
             <a:pPr algn="l">
+              <a:buNone/>
               <a:defRPr sz="1425" b="1">
                 <a:solidFill>
                   <a:srgbClr val="0B1720"/>
@@ -25286,6 +25535,7 @@
           <a:lstStyle xmlns:a="http://schemas.openxmlformats.org/drawingml/2006/main"/>
           <a:p xmlns:a="http://schemas.openxmlformats.org/drawingml/2006/main">
             <a:pPr algn="l">
+              <a:buNone/>
               <a:defRPr sz="1650" b="1">
                 <a:solidFill>
                   <a:srgbClr val="0B1720"/>
@@ -25439,6 +25689,7 @@
           <a:lstStyle xmlns:a="http://schemas.openxmlformats.org/drawingml/2006/main"/>
           <a:p xmlns:a="http://schemas.openxmlformats.org/drawingml/2006/main">
             <a:pPr algn="ctr">
+              <a:buNone/>
               <a:defRPr sz="975" b="1">
                 <a:solidFill>
                   <a:srgbClr val="F3C668"/>
@@ -25495,6 +25746,7 @@
           <a:lstStyle xmlns:a="http://schemas.openxmlformats.org/drawingml/2006/main"/>
           <a:p xmlns:a="http://schemas.openxmlformats.org/drawingml/2006/main">
             <a:pPr algn="l">
+              <a:buNone/>
               <a:defRPr sz="1425" b="1">
                 <a:solidFill>
                   <a:srgbClr val="0B1720"/>
@@ -25551,6 +25803,7 @@
           <a:lstStyle xmlns:a="http://schemas.openxmlformats.org/drawingml/2006/main"/>
           <a:p xmlns:a="http://schemas.openxmlformats.org/drawingml/2006/main">
             <a:pPr algn="l">
+              <a:buNone/>
               <a:defRPr sz="1650" b="1">
                 <a:solidFill>
                   <a:srgbClr val="0B1720"/>
@@ -25673,6 +25926,7 @@
           <a:lstStyle xmlns:a="http://schemas.openxmlformats.org/drawingml/2006/main"/>
           <a:p xmlns:a="http://schemas.openxmlformats.org/drawingml/2006/main">
             <a:pPr algn="ctr">
+              <a:buNone/>
               <a:defRPr sz="975" b="1">
                 <a:solidFill>
                   <a:srgbClr val="60D799"/>
@@ -25729,6 +25983,7 @@
           <a:lstStyle xmlns:a="http://schemas.openxmlformats.org/drawingml/2006/main"/>
           <a:p xmlns:a="http://schemas.openxmlformats.org/drawingml/2006/main">
             <a:pPr algn="l">
+              <a:buNone/>
               <a:defRPr sz="1425" b="1">
                 <a:solidFill>
                   <a:srgbClr val="0B1720"/>
@@ -25785,6 +26040,7 @@
           <a:lstStyle xmlns:a="http://schemas.openxmlformats.org/drawingml/2006/main"/>
           <a:p xmlns:a="http://schemas.openxmlformats.org/drawingml/2006/main">
             <a:pPr algn="l">
+              <a:buNone/>
               <a:defRPr sz="1650" b="1">
                 <a:solidFill>
                   <a:srgbClr val="0B1720"/>
@@ -25938,6 +26194,7 @@
           <a:lstStyle xmlns:a="http://schemas.openxmlformats.org/drawingml/2006/main"/>
           <a:p xmlns:a="http://schemas.openxmlformats.org/drawingml/2006/main">
             <a:pPr algn="ctr">
+              <a:buNone/>
               <a:defRPr sz="975" b="1">
                 <a:solidFill>
                   <a:srgbClr val="AA91FF"/>
@@ -25994,6 +26251,7 @@
           <a:lstStyle xmlns:a="http://schemas.openxmlformats.org/drawingml/2006/main"/>
           <a:p xmlns:a="http://schemas.openxmlformats.org/drawingml/2006/main">
             <a:pPr algn="l">
+              <a:buNone/>
               <a:defRPr sz="1425" b="1">
                 <a:solidFill>
                   <a:srgbClr val="0B1720"/>
@@ -26050,6 +26308,7 @@
           <a:lstStyle xmlns:a="http://schemas.openxmlformats.org/drawingml/2006/main"/>
           <a:p xmlns:a="http://schemas.openxmlformats.org/drawingml/2006/main">
             <a:pPr algn="l">
+              <a:buNone/>
               <a:defRPr sz="1650" b="1">
                 <a:solidFill>
                   <a:srgbClr val="0B1720"/>
@@ -26203,6 +26462,7 @@
           <a:lstStyle xmlns:a="http://schemas.openxmlformats.org/drawingml/2006/main"/>
           <a:p xmlns:a="http://schemas.openxmlformats.org/drawingml/2006/main">
             <a:pPr algn="ctr">
+              <a:buNone/>
               <a:defRPr sz="975" b="1">
                 <a:solidFill>
                   <a:srgbClr val="FF7487"/>
@@ -26259,6 +26519,7 @@
           <a:lstStyle xmlns:a="http://schemas.openxmlformats.org/drawingml/2006/main"/>
           <a:p xmlns:a="http://schemas.openxmlformats.org/drawingml/2006/main">
             <a:pPr algn="l">
+              <a:buNone/>
               <a:defRPr sz="1425" b="1">
                 <a:solidFill>
                   <a:srgbClr val="0B1720"/>
@@ -26315,6 +26576,7 @@
           <a:lstStyle xmlns:a="http://schemas.openxmlformats.org/drawingml/2006/main"/>
           <a:p xmlns:a="http://schemas.openxmlformats.org/drawingml/2006/main">
             <a:pPr algn="l">
+              <a:buNone/>
               <a:defRPr sz="1650" b="1">
                 <a:solidFill>
                   <a:srgbClr val="0B1720"/>
@@ -26402,6 +26664,7 @@
           <a:lstStyle xmlns:a="http://schemas.openxmlformats.org/drawingml/2006/main"/>
           <a:p xmlns:a="http://schemas.openxmlformats.org/drawingml/2006/main">
             <a:pPr algn="r">
+              <a:buNone/>
               <a:defRPr sz="825" b="1">
                 <a:solidFill>
                   <a:srgbClr val="5F7078"/>
@@ -27448,6 +27711,7 @@
           <a:lstStyle xmlns:a="http://schemas.openxmlformats.org/drawingml/2006/main"/>
           <a:p xmlns:a="http://schemas.openxmlformats.org/drawingml/2006/main">
             <a:pPr algn="l">
+              <a:buNone/>
               <a:defRPr sz="900" b="1">
                 <a:solidFill>
                   <a:srgbClr val="83F3C9"/>
@@ -27504,6 +27768,7 @@
           <a:lstStyle xmlns:a="http://schemas.openxmlformats.org/drawingml/2006/main"/>
           <a:p xmlns:a="http://schemas.openxmlformats.org/drawingml/2006/main">
             <a:pPr algn="l">
+              <a:buNone/>
               <a:defRPr sz="3300" b="1">
                 <a:solidFill>
                   <a:srgbClr val="F7F8F5"/>
@@ -27595,6 +27860,7 @@
           <a:lstStyle xmlns:a="http://schemas.openxmlformats.org/drawingml/2006/main"/>
           <a:p xmlns:a="http://schemas.openxmlformats.org/drawingml/2006/main">
             <a:pPr algn="ctr">
+              <a:buNone/>
               <a:defRPr sz="825" b="1">
                 <a:solidFill>
                   <a:srgbClr val="7AA7FF"/>
@@ -27651,6 +27917,7 @@
           <a:lstStyle xmlns:a="http://schemas.openxmlformats.org/drawingml/2006/main"/>
           <a:p xmlns:a="http://schemas.openxmlformats.org/drawingml/2006/main">
             <a:pPr algn="ctr">
+              <a:buNone/>
               <a:defRPr sz="1650" b="1">
                 <a:solidFill>
                   <a:srgbClr val="F7F8F5"/>
@@ -27707,6 +27974,7 @@
           <a:lstStyle xmlns:a="http://schemas.openxmlformats.org/drawingml/2006/main"/>
           <a:p xmlns:a="http://schemas.openxmlformats.org/drawingml/2006/main">
             <a:pPr algn="ctr">
+              <a:buNone/>
               <a:defRPr sz="975" b="0">
                 <a:solidFill>
                   <a:srgbClr val="9AA8AE"/>
@@ -27763,6 +28031,7 @@
           <a:lstStyle xmlns:a="http://schemas.openxmlformats.org/drawingml/2006/main"/>
           <a:p xmlns:a="http://schemas.openxmlformats.org/drawingml/2006/main">
             <a:pPr algn="ctr">
+              <a:buNone/>
               <a:defRPr sz="2250" b="0">
                 <a:solidFill>
                   <a:srgbClr val="9AA8AE"/>
@@ -27854,6 +28123,7 @@
           <a:lstStyle xmlns:a="http://schemas.openxmlformats.org/drawingml/2006/main"/>
           <a:p xmlns:a="http://schemas.openxmlformats.org/drawingml/2006/main">
             <a:pPr algn="ctr">
+              <a:buNone/>
               <a:defRPr sz="825" b="1">
                 <a:solidFill>
                   <a:srgbClr val="51DFE3"/>
@@ -27910,6 +28180,7 @@
           <a:lstStyle xmlns:a="http://schemas.openxmlformats.org/drawingml/2006/main"/>
           <a:p xmlns:a="http://schemas.openxmlformats.org/drawingml/2006/main">
             <a:pPr algn="ctr">
+              <a:buNone/>
               <a:defRPr sz="1650" b="1">
                 <a:solidFill>
                   <a:srgbClr val="F7F8F5"/>
@@ -27966,6 +28237,7 @@
           <a:lstStyle xmlns:a="http://schemas.openxmlformats.org/drawingml/2006/main"/>
           <a:p xmlns:a="http://schemas.openxmlformats.org/drawingml/2006/main">
             <a:pPr algn="ctr">
+              <a:buNone/>
               <a:defRPr sz="975" b="0">
                 <a:solidFill>
                   <a:srgbClr val="9AA8AE"/>
@@ -28022,6 +28294,7 @@
           <a:lstStyle xmlns:a="http://schemas.openxmlformats.org/drawingml/2006/main"/>
           <a:p xmlns:a="http://schemas.openxmlformats.org/drawingml/2006/main">
             <a:pPr algn="ctr">
+              <a:buNone/>
               <a:defRPr sz="2250" b="0">
                 <a:solidFill>
                   <a:srgbClr val="9AA8AE"/>
@@ -28113,6 +28386,7 @@
           <a:lstStyle xmlns:a="http://schemas.openxmlformats.org/drawingml/2006/main"/>
           <a:p xmlns:a="http://schemas.openxmlformats.org/drawingml/2006/main">
             <a:pPr algn="ctr">
+              <a:buNone/>
               <a:defRPr sz="825" b="1">
                 <a:solidFill>
                   <a:srgbClr val="F3C668"/>
@@ -28169,6 +28443,7 @@
           <a:lstStyle xmlns:a="http://schemas.openxmlformats.org/drawingml/2006/main"/>
           <a:p xmlns:a="http://schemas.openxmlformats.org/drawingml/2006/main">
             <a:pPr algn="ctr">
+              <a:buNone/>
               <a:defRPr sz="1650" b="1">
                 <a:solidFill>
                   <a:srgbClr val="F7F8F5"/>
@@ -28225,6 +28500,7 @@
           <a:lstStyle xmlns:a="http://schemas.openxmlformats.org/drawingml/2006/main"/>
           <a:p xmlns:a="http://schemas.openxmlformats.org/drawingml/2006/main">
             <a:pPr algn="ctr">
+              <a:buNone/>
               <a:defRPr sz="975" b="0">
                 <a:solidFill>
                   <a:srgbClr val="9AA8AE"/>
@@ -28281,6 +28557,7 @@
           <a:lstStyle xmlns:a="http://schemas.openxmlformats.org/drawingml/2006/main"/>
           <a:p xmlns:a="http://schemas.openxmlformats.org/drawingml/2006/main">
             <a:pPr algn="ctr">
+              <a:buNone/>
               <a:defRPr sz="2250" b="0">
                 <a:solidFill>
                   <a:srgbClr val="9AA8AE"/>
@@ -28372,6 +28649,7 @@
           <a:lstStyle xmlns:a="http://schemas.openxmlformats.org/drawingml/2006/main"/>
           <a:p xmlns:a="http://schemas.openxmlformats.org/drawingml/2006/main">
             <a:pPr algn="ctr">
+              <a:buNone/>
               <a:defRPr sz="825" b="1">
                 <a:solidFill>
                   <a:srgbClr val="247B63"/>
@@ -28428,6 +28706,7 @@
           <a:lstStyle xmlns:a="http://schemas.openxmlformats.org/drawingml/2006/main"/>
           <a:p xmlns:a="http://schemas.openxmlformats.org/drawingml/2006/main">
             <a:pPr algn="ctr">
+              <a:buNone/>
               <a:defRPr sz="1650" b="1">
                 <a:solidFill>
                   <a:srgbClr val="0B1720"/>
@@ -28484,6 +28763,7 @@
           <a:lstStyle xmlns:a="http://schemas.openxmlformats.org/drawingml/2006/main"/>
           <a:p xmlns:a="http://schemas.openxmlformats.org/drawingml/2006/main">
             <a:pPr algn="ctr">
+              <a:buNone/>
               <a:defRPr sz="975" b="0">
                 <a:solidFill>
                   <a:srgbClr val="247B63"/>
@@ -28540,6 +28820,7 @@
           <a:lstStyle xmlns:a="http://schemas.openxmlformats.org/drawingml/2006/main"/>
           <a:p xmlns:a="http://schemas.openxmlformats.org/drawingml/2006/main">
             <a:pPr algn="ctr">
+              <a:buNone/>
               <a:defRPr sz="2850" b="0">
                 <a:solidFill>
                   <a:srgbClr val="83F3C9"/>
@@ -28596,6 +28877,7 @@
           <a:lstStyle xmlns:a="http://schemas.openxmlformats.org/drawingml/2006/main"/>
           <a:p xmlns:a="http://schemas.openxmlformats.org/drawingml/2006/main">
             <a:pPr algn="ctr">
+              <a:buNone/>
               <a:defRPr sz="975" b="1">
                 <a:solidFill>
                   <a:srgbClr val="83F3C9"/>
@@ -28687,6 +28969,7 @@
           <a:lstStyle xmlns:a="http://schemas.openxmlformats.org/drawingml/2006/main"/>
           <a:p xmlns:a="http://schemas.openxmlformats.org/drawingml/2006/main">
             <a:pPr algn="ctr">
+              <a:buNone/>
               <a:defRPr sz="750" b="1">
                 <a:solidFill>
                   <a:srgbClr val="7AA7FF"/>
@@ -28778,6 +29061,7 @@
           <a:lstStyle xmlns:a="http://schemas.openxmlformats.org/drawingml/2006/main"/>
           <a:p xmlns:a="http://schemas.openxmlformats.org/drawingml/2006/main">
             <a:pPr algn="ctr">
+              <a:buNone/>
               <a:defRPr sz="750" b="1">
                 <a:solidFill>
                   <a:srgbClr val="51DFE3"/>
@@ -28869,6 +29153,7 @@
           <a:lstStyle xmlns:a="http://schemas.openxmlformats.org/drawingml/2006/main"/>
           <a:p xmlns:a="http://schemas.openxmlformats.org/drawingml/2006/main">
             <a:pPr algn="ctr">
+              <a:buNone/>
               <a:defRPr sz="750" b="1">
                 <a:solidFill>
                   <a:srgbClr val="F3C668"/>
@@ -28960,6 +29245,7 @@
           <a:lstStyle xmlns:a="http://schemas.openxmlformats.org/drawingml/2006/main"/>
           <a:p xmlns:a="http://schemas.openxmlformats.org/drawingml/2006/main">
             <a:pPr algn="ctr">
+              <a:buNone/>
               <a:defRPr sz="750" b="1">
                 <a:solidFill>
                   <a:srgbClr val="60D799"/>
@@ -29051,6 +29337,7 @@
           <a:lstStyle xmlns:a="http://schemas.openxmlformats.org/drawingml/2006/main"/>
           <a:p xmlns:a="http://schemas.openxmlformats.org/drawingml/2006/main">
             <a:pPr algn="ctr">
+              <a:buNone/>
               <a:defRPr sz="750" b="1">
                 <a:solidFill>
                   <a:srgbClr val="AA91FF"/>
@@ -29142,6 +29429,7 @@
           <a:lstStyle xmlns:a="http://schemas.openxmlformats.org/drawingml/2006/main"/>
           <a:p xmlns:a="http://schemas.openxmlformats.org/drawingml/2006/main">
             <a:pPr algn="ctr">
+              <a:buNone/>
               <a:defRPr sz="750" b="1">
                 <a:solidFill>
                   <a:srgbClr val="FF7487"/>
@@ -29198,6 +29486,7 @@
           <a:lstStyle xmlns:a="http://schemas.openxmlformats.org/drawingml/2006/main"/>
           <a:p xmlns:a="http://schemas.openxmlformats.org/drawingml/2006/main">
             <a:pPr algn="r">
+              <a:buNone/>
               <a:defRPr sz="825" b="1">
                 <a:solidFill>
                   <a:srgbClr val="5F7078"/>
@@ -29252,21 +29541,21 @@
       </p:grpSpPr>
       <p:pic>
         <p:nvPicPr>
-          <p:cNvPr id="3" name=""/>
+          <p:cNvPr id="4" name=""/>
           <p:cNvPicPr>
             <a:picLocks xmlns:a="http://schemas.openxmlformats.org/drawingml/2006/main" noChangeAspect="1"/>
           </p:cNvPicPr>
           <p:nvPr/>
         </p:nvPicPr>
         <p:blipFill>
-          <a:blip xmlns:r="http://schemas.openxmlformats.org/officeDocument/2006/relationships" xmlns:a="http://schemas.openxmlformats.org/drawingml/2006/main" r:embed="R08f84f0625504d0d"/>
+          <a:blip xmlns:r="http://schemas.openxmlformats.org/officeDocument/2006/relationships" xmlns:a="http://schemas.openxmlformats.org/drawingml/2006/main" r:embed="Rcc0a76105ab54836"/>
           <a:srcRect xmlns:a="http://schemas.openxmlformats.org/drawingml/2006/main" l="0" t="0" r="0" b="0"/>
           <a:stretch xmlns:a="http://schemas.openxmlformats.org/drawingml/2006/main">
             <a:fillRect l="0" t="0" r="0" b="0"/>
           </a:stretch>
         </p:blipFill>
         <p:spPr>
-          <a:xfrm xmlns:a="http://schemas.openxmlformats.org/drawingml/2006/main">
+          <a:xfrm xmlns:a="http://schemas.openxmlformats.org/drawingml/2006/main" flipH="0" flipV="0">
             <a:off x="0" y="0"/>
             <a:ext cx="12192000" cy="6858000"/>
           </a:xfrm>
@@ -29308,6 +29597,7 @@
           <a:lstStyle xmlns:a="http://schemas.openxmlformats.org/drawingml/2006/main"/>
           <a:p xmlns:a="http://schemas.openxmlformats.org/drawingml/2006/main">
             <a:pPr algn="r">
+              <a:buNone/>
               <a:defRPr sz="750" b="1">
                 <a:solidFill>
                   <a:srgbClr val="6F858D"/>
@@ -30354,6 +30644,7 @@
           <a:lstStyle xmlns:a="http://schemas.openxmlformats.org/drawingml/2006/main"/>
           <a:p xmlns:a="http://schemas.openxmlformats.org/drawingml/2006/main">
             <a:pPr algn="l">
+              <a:buNone/>
               <a:defRPr sz="900" b="1">
                 <a:solidFill>
                   <a:srgbClr val="83F3C9"/>
@@ -30410,6 +30701,7 @@
           <a:lstStyle xmlns:a="http://schemas.openxmlformats.org/drawingml/2006/main"/>
           <a:p xmlns:a="http://schemas.openxmlformats.org/drawingml/2006/main">
             <a:pPr algn="l">
+              <a:buNone/>
               <a:defRPr sz="3300" b="1">
                 <a:solidFill>
                   <a:srgbClr val="F7F8F5"/>
@@ -30466,6 +30758,7 @@
           <a:lstStyle xmlns:a="http://schemas.openxmlformats.org/drawingml/2006/main"/>
           <a:p xmlns:a="http://schemas.openxmlformats.org/drawingml/2006/main">
             <a:pPr algn="l">
+              <a:buNone/>
               <a:defRPr sz="1500" b="0">
                 <a:solidFill>
                   <a:srgbClr val="9AA8AE"/>
@@ -30590,6 +30883,7 @@
           <a:lstStyle xmlns:a="http://schemas.openxmlformats.org/drawingml/2006/main"/>
           <a:p xmlns:a="http://schemas.openxmlformats.org/drawingml/2006/main">
             <a:pPr algn="l">
+              <a:buNone/>
               <a:defRPr sz="825" b="1">
                 <a:solidFill>
                   <a:srgbClr val="FF7487"/>
@@ -30646,6 +30940,7 @@
           <a:lstStyle xmlns:a="http://schemas.openxmlformats.org/drawingml/2006/main"/>
           <a:p xmlns:a="http://schemas.openxmlformats.org/drawingml/2006/main">
             <a:pPr algn="l">
+              <a:buNone/>
               <a:defRPr sz="1500" b="1">
                 <a:solidFill>
                   <a:srgbClr val="F7F8F5"/>
@@ -30702,6 +30997,7 @@
           <a:lstStyle xmlns:a="http://schemas.openxmlformats.org/drawingml/2006/main"/>
           <a:p xmlns:a="http://schemas.openxmlformats.org/drawingml/2006/main">
             <a:pPr algn="r">
+              <a:buNone/>
               <a:defRPr sz="900" b="0">
                 <a:solidFill>
                   <a:srgbClr val="9AA8AE"/>
@@ -30826,6 +31122,7 @@
           <a:lstStyle xmlns:a="http://schemas.openxmlformats.org/drawingml/2006/main"/>
           <a:p xmlns:a="http://schemas.openxmlformats.org/drawingml/2006/main">
             <a:pPr algn="l">
+              <a:buNone/>
               <a:defRPr sz="825" b="1">
                 <a:solidFill>
                   <a:srgbClr val="F3C668"/>
@@ -30882,6 +31179,7 @@
           <a:lstStyle xmlns:a="http://schemas.openxmlformats.org/drawingml/2006/main"/>
           <a:p xmlns:a="http://schemas.openxmlformats.org/drawingml/2006/main">
             <a:pPr algn="l">
+              <a:buNone/>
               <a:defRPr sz="1500" b="1">
                 <a:solidFill>
                   <a:srgbClr val="F7F8F5"/>
@@ -30938,6 +31236,7 @@
           <a:lstStyle xmlns:a="http://schemas.openxmlformats.org/drawingml/2006/main"/>
           <a:p xmlns:a="http://schemas.openxmlformats.org/drawingml/2006/main">
             <a:pPr algn="r">
+              <a:buNone/>
               <a:defRPr sz="900" b="0">
                 <a:solidFill>
                   <a:srgbClr val="9AA8AE"/>
@@ -31062,6 +31361,7 @@
           <a:lstStyle xmlns:a="http://schemas.openxmlformats.org/drawingml/2006/main"/>
           <a:p xmlns:a="http://schemas.openxmlformats.org/drawingml/2006/main">
             <a:pPr algn="l">
+              <a:buNone/>
               <a:defRPr sz="825" b="1">
                 <a:solidFill>
                   <a:srgbClr val="FF7487"/>
@@ -31118,6 +31418,7 @@
           <a:lstStyle xmlns:a="http://schemas.openxmlformats.org/drawingml/2006/main"/>
           <a:p xmlns:a="http://schemas.openxmlformats.org/drawingml/2006/main">
             <a:pPr algn="l">
+              <a:buNone/>
               <a:defRPr sz="1500" b="1">
                 <a:solidFill>
                   <a:srgbClr val="F7F8F5"/>
@@ -31174,6 +31475,7 @@
           <a:lstStyle xmlns:a="http://schemas.openxmlformats.org/drawingml/2006/main"/>
           <a:p xmlns:a="http://schemas.openxmlformats.org/drawingml/2006/main">
             <a:pPr algn="r">
+              <a:buNone/>
               <a:defRPr sz="900" b="0">
                 <a:solidFill>
                   <a:srgbClr val="9AA8AE"/>
@@ -31298,6 +31600,7 @@
           <a:lstStyle xmlns:a="http://schemas.openxmlformats.org/drawingml/2006/main"/>
           <a:p xmlns:a="http://schemas.openxmlformats.org/drawingml/2006/main">
             <a:pPr algn="l">
+              <a:buNone/>
               <a:defRPr sz="825" b="1">
                 <a:solidFill>
                   <a:srgbClr val="F3C668"/>
@@ -31354,6 +31657,7 @@
           <a:lstStyle xmlns:a="http://schemas.openxmlformats.org/drawingml/2006/main"/>
           <a:p xmlns:a="http://schemas.openxmlformats.org/drawingml/2006/main">
             <a:pPr algn="l">
+              <a:buNone/>
               <a:defRPr sz="1500" b="1">
                 <a:solidFill>
                   <a:srgbClr val="F7F8F5"/>
@@ -31410,6 +31714,7 @@
           <a:lstStyle xmlns:a="http://schemas.openxmlformats.org/drawingml/2006/main"/>
           <a:p xmlns:a="http://schemas.openxmlformats.org/drawingml/2006/main">
             <a:pPr algn="r">
+              <a:buNone/>
               <a:defRPr sz="900" b="0">
                 <a:solidFill>
                   <a:srgbClr val="9AA8AE"/>
@@ -31501,6 +31806,7 @@
           <a:lstStyle xmlns:a="http://schemas.openxmlformats.org/drawingml/2006/main"/>
           <a:p xmlns:a="http://schemas.openxmlformats.org/drawingml/2006/main">
             <a:pPr algn="ctr">
+              <a:buNone/>
               <a:defRPr sz="750" b="1">
                 <a:solidFill>
                   <a:srgbClr val="83F3C9"/>
@@ -31557,6 +31863,7 @@
           <a:lstStyle xmlns:a="http://schemas.openxmlformats.org/drawingml/2006/main"/>
           <a:p xmlns:a="http://schemas.openxmlformats.org/drawingml/2006/main">
             <a:pPr algn="r">
+              <a:buNone/>
               <a:defRPr sz="825" b="0">
                 <a:solidFill>
                   <a:srgbClr val="9AA8AE"/>
@@ -31613,6 +31920,7 @@
           <a:lstStyle xmlns:a="http://schemas.openxmlformats.org/drawingml/2006/main"/>
           <a:p xmlns:a="http://schemas.openxmlformats.org/drawingml/2006/main">
             <a:pPr algn="r">
+              <a:buNone/>
               <a:defRPr sz="825" b="1">
                 <a:solidFill>
                   <a:srgbClr val="5F7078"/>

</xml_diff>